<commit_message>
Optimize notebook + slides for judging rubric
</commit_message>
<xml_diff>
--- a/submissions/2kim_health_slides.pptx
+++ b/submissions/2kim_health_slides.pptx
@@ -18,7 +18,6 @@
     <p:sldId id="266" r:id="rId17"/>
     <p:sldId id="267" r:id="rId18"/>
     <p:sldId id="268" r:id="rId19"/>
-    <p:sldId id="269" r:id="rId20"/>
   </p:sldIdLst>
   <p:sldSz cx="12191695" cy="6858000" type="screen4x3"/>
   <p:notesSz cx="6858000" cy="9144000"/>
@@ -3117,7 +3116,7 @@
         </p:nvSpPr>
         <p:spPr>
           <a:xfrm>
-            <a:off x="914400" y="1371600"/>
+            <a:off x="914400" y="1097280"/>
             <a:ext cx="10058400" cy="1371600"/>
           </a:xfrm>
           <a:prstGeom prst="rect">
@@ -3132,7 +3131,7 @@
           <a:lstStyle/>
           <a:p>
             <a:pPr algn="ctr">
-              <a:defRPr sz="4000" b="1">
+              <a:defRPr sz="4200" b="1">
                 <a:solidFill>
                   <a:srgbClr val="FFFFFF"/>
                 </a:solidFill>
@@ -3152,7 +3151,7 @@
         </p:nvSpPr>
         <p:spPr>
           <a:xfrm>
-            <a:off x="914400" y="2926080"/>
+            <a:off x="914400" y="2743200"/>
             <a:ext cx="10058400" cy="731520"/>
           </a:xfrm>
           <a:prstGeom prst="rect">
@@ -3187,7 +3186,7 @@
         </p:nvSpPr>
         <p:spPr>
           <a:xfrm>
-            <a:off x="914400" y="4114800"/>
+            <a:off x="914400" y="3931920"/>
             <a:ext cx="10058400" cy="457200"/>
           </a:xfrm>
           <a:prstGeom prst="rect">
@@ -3202,7 +3201,7 @@
           <a:lstStyle/>
           <a:p>
             <a:pPr algn="ctr">
-              <a:defRPr sz="1800" b="0">
+              <a:defRPr sz="2000" b="0">
                 <a:solidFill>
                   <a:srgbClr val="1F6FEB"/>
                 </a:solidFill>
@@ -3222,7 +3221,7 @@
         </p:nvSpPr>
         <p:spPr>
           <a:xfrm>
-            <a:off x="914400" y="4754880"/>
+            <a:off x="914400" y="4572000"/>
             <a:ext cx="10058400" cy="457200"/>
           </a:xfrm>
           <a:prstGeom prst="rect">
@@ -3245,6 +3244,45 @@
             </a:pPr>
             <a:r>
               <a:t>SBU AI Community Datathon 2026  |  Healthcare &amp; Wellness Track</a:t>
+            </a:r>
+          </a:p>
+        </p:txBody>
+      </p:sp>
+      <p:sp>
+        <p:nvSpPr>
+          <p:cNvPr id="6" name="TextBox 5"/>
+          <p:cNvSpPr txBox="1"/>
+          <p:nvPr/>
+        </p:nvSpPr>
+        <p:spPr>
+          <a:xfrm>
+            <a:off x="914400" y="5486400"/>
+            <a:ext cx="10058400" cy="731520"/>
+          </a:xfrm>
+          <a:prstGeom prst="rect">
+            <a:avLst/>
+          </a:prstGeom>
+          <a:noFill/>
+        </p:spPr>
+        <p:txBody>
+          <a:bodyPr wrap="square">
+            <a:spAutoFit/>
+          </a:bodyPr>
+          <a:lstStyle/>
+          <a:p>
+            <a:pPr algn="ctr">
+              <a:defRPr sz="1500" b="0">
+                <a:solidFill>
+                  <a:srgbClr val="F0883E"/>
+                </a:solidFill>
+              </a:defRPr>
+            </a:pPr>
+            <a:r>
+              <a:t>37 million Americans have diabetes ($327B/year). 19 million live in food deserts.</a:t>
+            </a:r>
+            <a:br/>
+            <a:r>
+              <a:t>Are these the same people? And is it their fault — or their zip code's?</a:t>
             </a:r>
           </a:p>
         </p:txBody>
@@ -3283,8 +3321,8 @@
         </p:nvSpPr>
         <p:spPr>
           <a:xfrm>
-            <a:off x="731520" y="274320"/>
-            <a:ext cx="7315200" cy="457200"/>
+            <a:off x="731520" y="182880"/>
+            <a:ext cx="10058400" cy="457200"/>
           </a:xfrm>
           <a:prstGeom prst="rect">
             <a:avLst/>
@@ -3305,21 +3343,56 @@
               </a:defRPr>
             </a:pPr>
             <a:r>
-              <a:t>Finding 3: Race Persists After Controlling for Income</a:t>
-            </a:r>
-          </a:p>
-        </p:txBody>
-      </p:sp>
-      <p:sp>
-        <p:nvSpPr>
-          <p:cNvPr id="3" name="Rounded Rectangle 2"/>
+              <a:t>Health Disadvantage Index: Where Inequality Compounds</a:t>
+            </a:r>
+          </a:p>
+        </p:txBody>
+      </p:sp>
+      <p:sp>
+        <p:nvSpPr>
+          <p:cNvPr id="3" name="TextBox 2"/>
+          <p:cNvSpPr txBox="1"/>
+          <p:nvPr/>
+        </p:nvSpPr>
+        <p:spPr>
+          <a:xfrm>
+            <a:off x="731520" y="822960"/>
+            <a:ext cx="10058400" cy="365760"/>
+          </a:xfrm>
+          <a:prstGeom prst="rect">
+            <a:avLst/>
+          </a:prstGeom>
+          <a:noFill/>
+        </p:spPr>
+        <p:txBody>
+          <a:bodyPr wrap="square">
+            <a:spAutoFit/>
+          </a:bodyPr>
+          <a:lstStyle/>
+          <a:p>
+            <a:pPr algn="l">
+              <a:defRPr sz="1500" b="0">
+                <a:solidFill>
+                  <a:srgbClr val="8B949E"/>
+                </a:solidFill>
+              </a:defRPr>
+            </a:pPr>
+            <a:r>
+              <a:t>Equal-weighted composite: Food Access + Poverty + Healthcare Access (no circularity)</a:t>
+            </a:r>
+          </a:p>
+        </p:txBody>
+      </p:sp>
+      <p:sp>
+        <p:nvSpPr>
+          <p:cNvPr id="4" name="Rounded Rectangle 3"/>
           <p:cNvSpPr/>
           <p:nvPr/>
         </p:nvSpPr>
         <p:spPr>
           <a:xfrm>
-            <a:off x="731520" y="1005840"/>
-            <a:ext cx="3474720" cy="1188720"/>
+            <a:off x="731520" y="1371600"/>
+            <a:ext cx="2286000" cy="1188720"/>
           </a:xfrm>
           <a:prstGeom prst="roundRect">
             <a:avLst/>
@@ -3354,12 +3427,12 @@
             <a:pPr algn="ctr">
               <a:defRPr sz="2800" b="1">
                 <a:solidFill>
-                  <a:srgbClr val="2ECC71"/>
-                </a:solidFill>
-              </a:defRPr>
-            </a:pPr>
-            <a:r>
-              <a:t>R² 0.50 → 0.56</a:t>
+                  <a:srgbClr val="E74C3C"/>
+                </a:solidFill>
+              </a:defRPr>
+            </a:pPr>
+            <a:r>
+              <a:t>8.6pp</a:t>
             </a:r>
           </a:p>
           <a:p>
@@ -3371,25 +3444,25 @@
               </a:defRPr>
             </a:pPr>
             <a:r>
-              <a:t>Adding race improves model</a:t>
+              <a:t>Diabetes gap</a:t>
             </a:r>
             <a:br/>
             <a:r>
-              <a:t>(+6% explained variance)</a:t>
-            </a:r>
-          </a:p>
-        </p:txBody>
-      </p:sp>
-      <p:sp>
-        <p:nvSpPr>
-          <p:cNvPr id="4" name="Rounded Rectangle 3"/>
+              <a:t>worst vs best 10%</a:t>
+            </a:r>
+          </a:p>
+        </p:txBody>
+      </p:sp>
+      <p:sp>
+        <p:nvSpPr>
+          <p:cNvPr id="5" name="Rounded Rectangle 4"/>
           <p:cNvSpPr/>
           <p:nvPr/>
         </p:nvSpPr>
         <p:spPr>
           <a:xfrm>
-            <a:off x="4572000" y="1005840"/>
-            <a:ext cx="3474720" cy="1188720"/>
+            <a:off x="3291840" y="1371600"/>
+            <a:ext cx="2286000" cy="1188720"/>
           </a:xfrm>
           <a:prstGeom prst="roundRect">
             <a:avLst/>
@@ -3424,12 +3497,12 @@
             <a:pPr algn="ctr">
               <a:defRPr sz="2800" b="1">
                 <a:solidFill>
-                  <a:srgbClr val="1F6FEB"/>
-                </a:solidFill>
-              </a:defRPr>
-            </a:pPr>
-            <a:r>
-              <a:t>p ≈ 0</a:t>
+                  <a:srgbClr val="E74C3C"/>
+                </a:solidFill>
+              </a:defRPr>
+            </a:pPr>
+            <a:r>
+              <a:t>12.2pp</a:t>
             </a:r>
           </a:p>
           <a:p>
@@ -3441,49 +3514,165 @@
               </a:defRPr>
             </a:pPr>
             <a:r>
-              <a:t>Race is statistically</a:t>
+              <a:t>Obesity gap</a:t>
             </a:r>
             <a:br/>
             <a:r>
-              <a:t>significant</a:t>
-            </a:r>
-          </a:p>
-        </p:txBody>
-      </p:sp>
-      <p:pic>
-        <p:nvPicPr>
-          <p:cNvPr id="5" name="Picture 4" descr="eda-heatmap.png"/>
-          <p:cNvPicPr>
-            <a:picLocks noChangeAspect="1"/>
-          </p:cNvPicPr>
-          <p:nvPr/>
-        </p:nvPicPr>
-        <p:blipFill>
-          <a:blip r:embed="rId2"/>
-          <a:stretch>
-            <a:fillRect/>
-          </a:stretch>
-        </p:blipFill>
-        <p:spPr>
-          <a:xfrm>
-            <a:off x="457200" y="2468880"/>
-            <a:ext cx="5943600" cy="3840480"/>
-          </a:xfrm>
-          <a:prstGeom prst="rect">
-            <a:avLst/>
-          </a:prstGeom>
-        </p:spPr>
-      </p:pic>
-      <p:sp>
-        <p:nvSpPr>
-          <p:cNvPr id="6" name="TextBox 5"/>
+              <a:t>worst vs best 10%</a:t>
+            </a:r>
+          </a:p>
+        </p:txBody>
+      </p:sp>
+      <p:sp>
+        <p:nvSpPr>
+          <p:cNvPr id="6" name="Rounded Rectangle 5"/>
+          <p:cNvSpPr/>
+          <p:nvPr/>
+        </p:nvSpPr>
+        <p:spPr>
+          <a:xfrm>
+            <a:off x="5852160" y="1371600"/>
+            <a:ext cx="2286000" cy="1188720"/>
+          </a:xfrm>
+          <a:prstGeom prst="roundRect">
+            <a:avLst/>
+          </a:prstGeom>
+          <a:solidFill>
+            <a:srgbClr val="161B22"/>
+          </a:solidFill>
+          <a:ln w="12700">
+            <a:solidFill>
+              <a:srgbClr val="30363D"/>
+            </a:solidFill>
+          </a:ln>
+        </p:spPr>
+        <p:style>
+          <a:lnRef idx="1">
+            <a:schemeClr val="accent1"/>
+          </a:lnRef>
+          <a:fillRef idx="3">
+            <a:schemeClr val="accent1"/>
+          </a:fillRef>
+          <a:effectRef idx="2">
+            <a:schemeClr val="accent1"/>
+          </a:effectRef>
+          <a:fontRef idx="minor">
+            <a:schemeClr val="lt1"/>
+          </a:fontRef>
+        </p:style>
+        <p:txBody>
+          <a:bodyPr rtlCol="0" anchor="ctr" wrap="square"/>
+          <a:lstStyle/>
+          <a:p>
+            <a:pPr algn="ctr">
+              <a:defRPr sz="2800" b="1">
+                <a:solidFill>
+                  <a:srgbClr val="E74C3C"/>
+                </a:solidFill>
+              </a:defRPr>
+            </a:pPr>
+            <a:r>
+              <a:t>5.9 yrs</a:t>
+            </a:r>
+          </a:p>
+          <a:p>
+            <a:pPr algn="ctr">
+              <a:defRPr sz="1200">
+                <a:solidFill>
+                  <a:srgbClr val="8B949E"/>
+                </a:solidFill>
+              </a:defRPr>
+            </a:pPr>
+            <a:r>
+              <a:t>Life expectancy gap</a:t>
+            </a:r>
+            <a:br/>
+            <a:r>
+              <a:t>worst vs best 10%</a:t>
+            </a:r>
+          </a:p>
+        </p:txBody>
+      </p:sp>
+      <p:sp>
+        <p:nvSpPr>
+          <p:cNvPr id="7" name="Rounded Rectangle 6"/>
+          <p:cNvSpPr/>
+          <p:nvPr/>
+        </p:nvSpPr>
+        <p:spPr>
+          <a:xfrm>
+            <a:off x="8412480" y="1371600"/>
+            <a:ext cx="2286000" cy="1188720"/>
+          </a:xfrm>
+          <a:prstGeom prst="roundRect">
+            <a:avLst/>
+          </a:prstGeom>
+          <a:solidFill>
+            <a:srgbClr val="161B22"/>
+          </a:solidFill>
+          <a:ln w="12700">
+            <a:solidFill>
+              <a:srgbClr val="30363D"/>
+            </a:solidFill>
+          </a:ln>
+        </p:spPr>
+        <p:style>
+          <a:lnRef idx="1">
+            <a:schemeClr val="accent1"/>
+          </a:lnRef>
+          <a:fillRef idx="3">
+            <a:schemeClr val="accent1"/>
+          </a:fillRef>
+          <a:effectRef idx="2">
+            <a:schemeClr val="accent1"/>
+          </a:effectRef>
+          <a:fontRef idx="minor">
+            <a:schemeClr val="lt1"/>
+          </a:fontRef>
+        </p:style>
+        <p:txBody>
+          <a:bodyPr rtlCol="0" anchor="ctr" wrap="square"/>
+          <a:lstStyle/>
+          <a:p>
+            <a:pPr algn="ctr">
+              <a:defRPr sz="2800" b="1">
+                <a:solidFill>
+                  <a:srgbClr val="E74C3C"/>
+                </a:solidFill>
+              </a:defRPr>
+            </a:pPr>
+            <a:r>
+              <a:t>27.6pp</a:t>
+            </a:r>
+          </a:p>
+          <a:p>
+            <a:pPr algn="ctr">
+              <a:defRPr sz="1200">
+                <a:solidFill>
+                  <a:srgbClr val="8B949E"/>
+                </a:solidFill>
+              </a:defRPr>
+            </a:pPr>
+            <a:r>
+              <a:t>Poverty gap</a:t>
+            </a:r>
+            <a:br/>
+            <a:r>
+              <a:t>worst vs best 10%</a:t>
+            </a:r>
+          </a:p>
+        </p:txBody>
+      </p:sp>
+      <p:sp>
+        <p:nvSpPr>
+          <p:cNvPr id="8" name="TextBox 7"/>
           <p:cNvSpPr txBox="1"/>
           <p:nvPr/>
         </p:nvSpPr>
         <p:spPr>
           <a:xfrm>
-            <a:off x="6858000" y="2560320"/>
-            <a:ext cx="4572000" cy="365760"/>
+            <a:off x="731520" y="3017520"/>
+            <a:ext cx="10058400" cy="365760"/>
           </a:xfrm>
           <a:prstGeom prst="rect">
             <a:avLst/>
@@ -3497,28 +3686,28 @@
           <a:lstStyle/>
           <a:p>
             <a:pPr algn="l">
-              <a:defRPr sz="1800" b="1">
-                <a:solidFill>
-                  <a:srgbClr val="F0883E"/>
-                </a:solidFill>
-              </a:defRPr>
-            </a:pPr>
-            <a:r>
-              <a:t>Cross-Comparison:</a:t>
-            </a:r>
-          </a:p>
-        </p:txBody>
-      </p:sp>
-      <p:sp>
-        <p:nvSpPr>
-          <p:cNvPr id="7" name="TextBox 6"/>
+              <a:defRPr sz="2000" b="1">
+                <a:solidFill>
+                  <a:srgbClr val="FFFFFF"/>
+                </a:solidFill>
+              </a:defRPr>
+            </a:pPr>
+            <a:r>
+              <a:t>Pathway: Poverty → Food Desert → Obesity → Diabetes</a:t>
+            </a:r>
+          </a:p>
+        </p:txBody>
+      </p:sp>
+      <p:sp>
+        <p:nvSpPr>
+          <p:cNvPr id="9" name="TextBox 8"/>
           <p:cNvSpPr txBox="1"/>
           <p:nvPr/>
         </p:nvSpPr>
         <p:spPr>
           <a:xfrm>
-            <a:off x="6858000" y="3108960"/>
-            <a:ext cx="4846320" cy="1828800"/>
+            <a:off x="731520" y="3474720"/>
+            <a:ext cx="10058400" cy="1371600"/>
           </a:xfrm>
           <a:prstGeom prst="rect">
             <a:avLst/>
@@ -3531,104 +3720,47 @@
           </a:bodyPr>
           <a:lstStyle/>
           <a:p>
-            <a:pPr>
-              <a:spcAft>
-                <a:spcPts val="600"/>
-              </a:spcAft>
-              <a:defRPr sz="1400">
+            <a:pPr algn="l">
+              <a:defRPr sz="1500" b="0">
                 <a:solidFill>
                   <a:srgbClr val="FFFFFF"/>
                 </a:solidFill>
               </a:defRPr>
             </a:pPr>
             <a:r>
-              <a:t>High-income Black tracts: 12.96% diabetes</a:t>
-            </a:r>
-          </a:p>
-          <a:p>
-            <a:pPr>
-              <a:spcAft>
-                <a:spcPts val="600"/>
-              </a:spcAft>
-              <a:defRPr sz="1400">
-                <a:solidFill>
-                  <a:srgbClr val="FFFFFF"/>
-                </a:solidFill>
-              </a:defRPr>
-            </a:pPr>
-            <a:r>
-              <a:t>Low-income White tracts: 14.2% diabetes</a:t>
-            </a:r>
-          </a:p>
-          <a:p>
-            <a:pPr>
-              <a:spcAft>
-                <a:spcPts val="600"/>
-              </a:spcAft>
-              <a:defRPr sz="1400">
-                <a:solidFill>
-                  <a:srgbClr val="FFFFFF"/>
-                </a:solidFill>
-              </a:defRPr>
-            </a:pPr>
-          </a:p>
-          <a:p>
-            <a:pPr>
-              <a:spcAft>
-                <a:spcPts val="600"/>
-              </a:spcAft>
-              <a:defRPr sz="1400">
-                <a:solidFill>
-                  <a:srgbClr val="FFFFFF"/>
-                </a:solidFill>
-              </a:defRPr>
-            </a:pPr>
-            <a:r>
-              <a:t>Income narrows the gap but does not</a:t>
-            </a:r>
-          </a:p>
-          <a:p>
-            <a:pPr>
-              <a:spcAft>
-                <a:spcPts val="600"/>
-              </a:spcAft>
-              <a:defRPr sz="1400">
-                <a:solidFill>
-                  <a:srgbClr val="FFFFFF"/>
-                </a:solidFill>
-              </a:defRPr>
-            </a:pPr>
-            <a:r>
-              <a:t>close it — structural factors beyond</a:t>
-            </a:r>
-          </a:p>
-          <a:p>
-            <a:pPr>
-              <a:spcAft>
-                <a:spcPts val="600"/>
-              </a:spcAft>
-              <a:defRPr sz="1400">
-                <a:solidFill>
-                  <a:srgbClr val="FFFFFF"/>
-                </a:solidFill>
-              </a:defRPr>
-            </a:pPr>
-            <a:r>
-              <a:t>economics drive racial health disparities.</a:t>
-            </a:r>
-          </a:p>
-        </p:txBody>
-      </p:sp>
-      <p:sp>
-        <p:nvSpPr>
-          <p:cNvPr id="8" name="TextBox 7"/>
+              <a:t>Each link in this pathway shows a statistically significant bivariate association.</a:t>
+            </a:r>
+            <a:br/>
+            <a:br/>
+            <a:r>
+              <a:t>When food access, poverty, and healthcare shortage all stack up in the same tract,</a:t>
+            </a:r>
+            <a:br/>
+            <a:r>
+              <a:t>outcomes are dramatically worse. These are identifiable places — the data tells us</a:t>
+            </a:r>
+            <a:br/>
+            <a:r>
+              <a:t>exactly where intervention is most needed.</a:t>
+            </a:r>
+            <a:br/>
+            <a:br/>
+            <a:r>
+              <a:t>Note: These are bivariate associations, not formal mediation.</a:t>
+            </a:r>
+          </a:p>
+        </p:txBody>
+      </p:sp>
+      <p:sp>
+        <p:nvSpPr>
+          <p:cNvPr id="10" name="TextBox 9"/>
           <p:cNvSpPr txBox="1"/>
           <p:nvPr/>
         </p:nvSpPr>
         <p:spPr>
           <a:xfrm>
-            <a:off x="6858000" y="5303520"/>
-            <a:ext cx="4572000" cy="731520"/>
+            <a:off x="731520" y="5486400"/>
+            <a:ext cx="10058400" cy="731520"/>
           </a:xfrm>
           <a:prstGeom prst="rect">
             <a:avLst/>
@@ -3642,18 +3774,18 @@
           <a:lstStyle/>
           <a:p>
             <a:pPr algn="l">
-              <a:defRPr sz="1300" b="0">
-                <a:solidFill>
-                  <a:srgbClr val="8B949E"/>
-                </a:solidFill>
-              </a:defRPr>
-            </a:pPr>
-            <a:r>
-              <a:t>Method: OLS with continuous income x race</a:t>
+              <a:defRPr sz="1600" b="0">
+                <a:solidFill>
+                  <a:srgbClr val="F1C40F"/>
+                </a:solidFill>
+              </a:defRPr>
+            </a:pPr>
+            <a:r>
+              <a:t>The bottom line: a tract in the worst HDI decile has 8.6pp more diabetes, 12.2pp more</a:t>
             </a:r>
             <a:br/>
             <a:r>
-              <a:t>interaction term; residual R² comparison</a:t>
+              <a:t>obesity, and its residents die nearly 6 years earlier than a tract in the best decile.</a:t>
             </a:r>
           </a:p>
         </p:txBody>
@@ -3714,7 +3846,7 @@
               </a:defRPr>
             </a:pPr>
             <a:r>
-              <a:t>Health Disadvantage Index: Compounding Inequality</a:t>
+              <a:t>Honest Limitations</a:t>
             </a:r>
           </a:p>
         </p:txBody>
@@ -3727,7 +3859,7 @@
         </p:nvSpPr>
         <p:spPr>
           <a:xfrm>
-            <a:off x="731520" y="1005840"/>
+            <a:off x="731520" y="731520"/>
             <a:ext cx="10058400" cy="365760"/>
           </a:xfrm>
           <a:prstGeom prst="rect">
@@ -3742,304 +3874,28 @@
           <a:lstStyle/>
           <a:p>
             <a:pPr algn="l">
-              <a:defRPr sz="1600" b="0">
+              <a:defRPr sz="1500" b="0">
                 <a:solidFill>
                   <a:srgbClr val="8B949E"/>
                 </a:solidFill>
               </a:defRPr>
             </a:pPr>
             <a:r>
-              <a:t>Equal-weighted composite: Food Access + Poverty + Healthcare Access</a:t>
-            </a:r>
-          </a:p>
-        </p:txBody>
-      </p:sp>
-      <p:sp>
-        <p:nvSpPr>
-          <p:cNvPr id="4" name="Rounded Rectangle 3"/>
-          <p:cNvSpPr/>
-          <p:nvPr/>
-        </p:nvSpPr>
-        <p:spPr>
-          <a:xfrm>
-            <a:off x="731520" y="1645920"/>
-            <a:ext cx="2560320" cy="1188720"/>
-          </a:xfrm>
-          <a:prstGeom prst="roundRect">
-            <a:avLst/>
-          </a:prstGeom>
-          <a:solidFill>
-            <a:srgbClr val="161B22"/>
-          </a:solidFill>
-          <a:ln w="12700">
-            <a:solidFill>
-              <a:srgbClr val="30363D"/>
-            </a:solidFill>
-          </a:ln>
-        </p:spPr>
-        <p:style>
-          <a:lnRef idx="1">
-            <a:schemeClr val="accent1"/>
-          </a:lnRef>
-          <a:fillRef idx="3">
-            <a:schemeClr val="accent1"/>
-          </a:fillRef>
-          <a:effectRef idx="2">
-            <a:schemeClr val="accent1"/>
-          </a:effectRef>
-          <a:fontRef idx="minor">
-            <a:schemeClr val="lt1"/>
-          </a:fontRef>
-        </p:style>
-        <p:txBody>
-          <a:bodyPr rtlCol="0" anchor="ctr" wrap="square"/>
-          <a:lstStyle/>
-          <a:p>
-            <a:pPr algn="ctr">
-              <a:defRPr sz="2800" b="1">
-                <a:solidFill>
-                  <a:srgbClr val="E74C3C"/>
-                </a:solidFill>
-              </a:defRPr>
-            </a:pPr>
-            <a:r>
-              <a:t>8.6pp</a:t>
-            </a:r>
-          </a:p>
-          <a:p>
-            <a:pPr algn="ctr">
-              <a:defRPr sz="1200">
-                <a:solidFill>
-                  <a:srgbClr val="8B949E"/>
-                </a:solidFill>
-              </a:defRPr>
-            </a:pPr>
-            <a:r>
-              <a:t>Diabetes gap</a:t>
-            </a:r>
-            <a:br/>
-            <a:r>
-              <a:t>worst vs best decile</a:t>
-            </a:r>
-          </a:p>
-        </p:txBody>
-      </p:sp>
-      <p:sp>
-        <p:nvSpPr>
-          <p:cNvPr id="5" name="Rounded Rectangle 4"/>
-          <p:cNvSpPr/>
-          <p:nvPr/>
-        </p:nvSpPr>
-        <p:spPr>
-          <a:xfrm>
-            <a:off x="3566160" y="1645920"/>
-            <a:ext cx="2560320" cy="1188720"/>
-          </a:xfrm>
-          <a:prstGeom prst="roundRect">
-            <a:avLst/>
-          </a:prstGeom>
-          <a:solidFill>
-            <a:srgbClr val="161B22"/>
-          </a:solidFill>
-          <a:ln w="12700">
-            <a:solidFill>
-              <a:srgbClr val="30363D"/>
-            </a:solidFill>
-          </a:ln>
-        </p:spPr>
-        <p:style>
-          <a:lnRef idx="1">
-            <a:schemeClr val="accent1"/>
-          </a:lnRef>
-          <a:fillRef idx="3">
-            <a:schemeClr val="accent1"/>
-          </a:fillRef>
-          <a:effectRef idx="2">
-            <a:schemeClr val="accent1"/>
-          </a:effectRef>
-          <a:fontRef idx="minor">
-            <a:schemeClr val="lt1"/>
-          </a:fontRef>
-        </p:style>
-        <p:txBody>
-          <a:bodyPr rtlCol="0" anchor="ctr" wrap="square"/>
-          <a:lstStyle/>
-          <a:p>
-            <a:pPr algn="ctr">
-              <a:defRPr sz="2800" b="1">
-                <a:solidFill>
-                  <a:srgbClr val="E74C3C"/>
-                </a:solidFill>
-              </a:defRPr>
-            </a:pPr>
-            <a:r>
-              <a:t>12.2pp</a:t>
-            </a:r>
-          </a:p>
-          <a:p>
-            <a:pPr algn="ctr">
-              <a:defRPr sz="1200">
-                <a:solidFill>
-                  <a:srgbClr val="8B949E"/>
-                </a:solidFill>
-              </a:defRPr>
-            </a:pPr>
-            <a:r>
-              <a:t>Obesity gap</a:t>
-            </a:r>
-            <a:br/>
-            <a:r>
-              <a:t>worst vs best decile</a:t>
-            </a:r>
-          </a:p>
-        </p:txBody>
-      </p:sp>
-      <p:sp>
-        <p:nvSpPr>
-          <p:cNvPr id="6" name="Rounded Rectangle 5"/>
-          <p:cNvSpPr/>
-          <p:nvPr/>
-        </p:nvSpPr>
-        <p:spPr>
-          <a:xfrm>
-            <a:off x="6400800" y="1645920"/>
-            <a:ext cx="2560320" cy="1188720"/>
-          </a:xfrm>
-          <a:prstGeom prst="roundRect">
-            <a:avLst/>
-          </a:prstGeom>
-          <a:solidFill>
-            <a:srgbClr val="161B22"/>
-          </a:solidFill>
-          <a:ln w="12700">
-            <a:solidFill>
-              <a:srgbClr val="30363D"/>
-            </a:solidFill>
-          </a:ln>
-        </p:spPr>
-        <p:style>
-          <a:lnRef idx="1">
-            <a:schemeClr val="accent1"/>
-          </a:lnRef>
-          <a:fillRef idx="3">
-            <a:schemeClr val="accent1"/>
-          </a:fillRef>
-          <a:effectRef idx="2">
-            <a:schemeClr val="accent1"/>
-          </a:effectRef>
-          <a:fontRef idx="minor">
-            <a:schemeClr val="lt1"/>
-          </a:fontRef>
-        </p:style>
-        <p:txBody>
-          <a:bodyPr rtlCol="0" anchor="ctr" wrap="square"/>
-          <a:lstStyle/>
-          <a:p>
-            <a:pPr algn="ctr">
-              <a:defRPr sz="2800" b="1">
-                <a:solidFill>
-                  <a:srgbClr val="E74C3C"/>
-                </a:solidFill>
-              </a:defRPr>
-            </a:pPr>
-            <a:r>
-              <a:t>5.9 yrs</a:t>
-            </a:r>
-          </a:p>
-          <a:p>
-            <a:pPr algn="ctr">
-              <a:defRPr sz="1200">
-                <a:solidFill>
-                  <a:srgbClr val="8B949E"/>
-                </a:solidFill>
-              </a:defRPr>
-            </a:pPr>
-            <a:r>
-              <a:t>Life expectancy gap</a:t>
-            </a:r>
-            <a:br/>
-            <a:r>
-              <a:t>worst vs best decile</a:t>
-            </a:r>
-          </a:p>
-        </p:txBody>
-      </p:sp>
-      <p:sp>
-        <p:nvSpPr>
-          <p:cNvPr id="7" name="Rounded Rectangle 6"/>
-          <p:cNvSpPr/>
-          <p:nvPr/>
-        </p:nvSpPr>
-        <p:spPr>
-          <a:xfrm>
-            <a:off x="9235440" y="1645920"/>
-            <a:ext cx="2286000" cy="1188720"/>
-          </a:xfrm>
-          <a:prstGeom prst="roundRect">
-            <a:avLst/>
-          </a:prstGeom>
-          <a:solidFill>
-            <a:srgbClr val="161B22"/>
-          </a:solidFill>
-          <a:ln w="12700">
-            <a:solidFill>
-              <a:srgbClr val="30363D"/>
-            </a:solidFill>
-          </a:ln>
-        </p:spPr>
-        <p:style>
-          <a:lnRef idx="1">
-            <a:schemeClr val="accent1"/>
-          </a:lnRef>
-          <a:fillRef idx="3">
-            <a:schemeClr val="accent1"/>
-          </a:fillRef>
-          <a:effectRef idx="2">
-            <a:schemeClr val="accent1"/>
-          </a:effectRef>
-          <a:fontRef idx="minor">
-            <a:schemeClr val="lt1"/>
-          </a:fontRef>
-        </p:style>
-        <p:txBody>
-          <a:bodyPr rtlCol="0" anchor="ctr" wrap="square"/>
-          <a:lstStyle/>
-          <a:p>
-            <a:pPr algn="ctr">
-              <a:defRPr sz="2800" b="1">
-                <a:solidFill>
-                  <a:srgbClr val="E74C3C"/>
-                </a:solidFill>
-              </a:defRPr>
-            </a:pPr>
-            <a:r>
-              <a:t>27.6pp</a:t>
-            </a:r>
-          </a:p>
-          <a:p>
-            <a:pPr algn="ctr">
-              <a:defRPr sz="1200">
-                <a:solidFill>
-                  <a:srgbClr val="8B949E"/>
-                </a:solidFill>
-              </a:defRPr>
-            </a:pPr>
-            <a:r>
-              <a:t>Poverty gap</a:t>
-            </a:r>
-          </a:p>
-        </p:txBody>
-      </p:sp>
-      <p:sp>
-        <p:nvSpPr>
-          <p:cNvPr id="8" name="TextBox 7"/>
+              <a:t>We believe transparency strengthens, not weakens, our analysis.</a:t>
+            </a:r>
+          </a:p>
+        </p:txBody>
+      </p:sp>
+      <p:sp>
+        <p:nvSpPr>
+          <p:cNvPr id="4" name="TextBox 3"/>
           <p:cNvSpPr txBox="1"/>
           <p:nvPr/>
         </p:nvSpPr>
         <p:spPr>
           <a:xfrm>
-            <a:off x="731520" y="3200400"/>
-            <a:ext cx="10058400" cy="365760"/>
+            <a:off x="731520" y="1188720"/>
+            <a:ext cx="2743200" cy="320040"/>
           </a:xfrm>
           <a:prstGeom prst="rect">
             <a:avLst/>
@@ -4053,28 +3909,28 @@
           <a:lstStyle/>
           <a:p>
             <a:pPr algn="l">
-              <a:defRPr sz="1800" b="1">
-                <a:solidFill>
-                  <a:srgbClr val="FFFFFF"/>
-                </a:solidFill>
-              </a:defRPr>
-            </a:pPr>
-            <a:r>
-              <a:t>Pathway: Poverty → Food Desert → Obesity → Diabetes</a:t>
-            </a:r>
-          </a:p>
-        </p:txBody>
-      </p:sp>
-      <p:sp>
-        <p:nvSpPr>
-          <p:cNvPr id="9" name="TextBox 8"/>
+              <a:defRPr sz="1400" b="1">
+                <a:solidFill>
+                  <a:srgbClr val="F0883E"/>
+                </a:solidFill>
+              </a:defRPr>
+            </a:pPr>
+            <a:r>
+              <a:t>Ecological fallacy</a:t>
+            </a:r>
+          </a:p>
+        </p:txBody>
+      </p:sp>
+      <p:sp>
+        <p:nvSpPr>
+          <p:cNvPr id="5" name="TextBox 4"/>
           <p:cNvSpPr txBox="1"/>
           <p:nvPr/>
         </p:nvSpPr>
         <p:spPr>
           <a:xfrm>
-            <a:off x="731520" y="3657600"/>
-            <a:ext cx="10058400" cy="1097280"/>
+            <a:off x="3657600" y="1188720"/>
+            <a:ext cx="8229600" cy="320040"/>
           </a:xfrm>
           <a:prstGeom prst="rect">
             <a:avLst/>
@@ -4088,40 +3944,28 @@
           <a:lstStyle/>
           <a:p>
             <a:pPr algn="l">
-              <a:defRPr sz="1500" b="0">
+              <a:defRPr sz="1300" b="0">
                 <a:solidFill>
                   <a:srgbClr val="FFFFFF"/>
                 </a:solidFill>
               </a:defRPr>
             </a:pPr>
             <a:r>
-              <a:t>Each link in the pathway shows a statistically significant bivariate association.</a:t>
-            </a:r>
-            <a:br/>
-            <a:r>
-              <a:t>When food access, poverty, and healthcare shortage all stack up in the same tract,</a:t>
-            </a:r>
-            <a:br/>
-            <a:r>
-              <a:t>outcomes are dramatically worse. These tracts are identifiable — the data tells us</a:t>
-            </a:r>
-            <a:br/>
-            <a:r>
-              <a:t>exactly where intervention is most needed.</a:t>
-            </a:r>
-          </a:p>
-        </p:txBody>
-      </p:sp>
-      <p:sp>
-        <p:nvSpPr>
-          <p:cNvPr id="10" name="TextBox 9"/>
+              <a:t>Tract-level data — we cannot infer individual risk from area-level patterns</a:t>
+            </a:r>
+          </a:p>
+        </p:txBody>
+      </p:sp>
+      <p:sp>
+        <p:nvSpPr>
+          <p:cNvPr id="6" name="TextBox 5"/>
           <p:cNvSpPr txBox="1"/>
           <p:nvPr/>
         </p:nvSpPr>
         <p:spPr>
           <a:xfrm>
-            <a:off x="731520" y="5029200"/>
-            <a:ext cx="10058400" cy="731520"/>
+            <a:off x="731520" y="1755648"/>
+            <a:ext cx="2743200" cy="320040"/>
           </a:xfrm>
           <a:prstGeom prst="rect">
             <a:avLst/>
@@ -4135,18 +3979,469 @@
           <a:lstStyle/>
           <a:p>
             <a:pPr algn="l">
+              <a:defRPr sz="1400" b="1">
+                <a:solidFill>
+                  <a:srgbClr val="F0883E"/>
+                </a:solidFill>
+              </a:defRPr>
+            </a:pPr>
+            <a:r>
+              <a:t>Correlation ≠ causation</a:t>
+            </a:r>
+          </a:p>
+        </p:txBody>
+      </p:sp>
+      <p:sp>
+        <p:nvSpPr>
+          <p:cNvPr id="7" name="TextBox 6"/>
+          <p:cNvSpPr txBox="1"/>
+          <p:nvPr/>
+        </p:nvSpPr>
+        <p:spPr>
+          <a:xfrm>
+            <a:off x="3657600" y="1755648"/>
+            <a:ext cx="8229600" cy="320040"/>
+          </a:xfrm>
+          <a:prstGeom prst="rect">
+            <a:avLst/>
+          </a:prstGeom>
+          <a:noFill/>
+        </p:spPr>
+        <p:txBody>
+          <a:bodyPr wrap="square">
+            <a:spAutoFit/>
+          </a:bodyPr>
+          <a:lstStyle/>
+          <a:p>
+            <a:pPr algn="l">
               <a:defRPr sz="1300" b="0">
                 <a:solidFill>
-                  <a:srgbClr val="8B949E"/>
-                </a:solidFill>
-              </a:defRPr>
-            </a:pPr>
-            <a:r>
-              <a:t>Note: The pathway shows bivariate associations, not formal mediation. Equal weights avoid</a:t>
-            </a:r>
-            <a:br/>
-            <a:r>
-              <a:t>circularity (deriving weights from same data used to validate).</a:t>
+                  <a:srgbClr val="FFFFFF"/>
+                </a:solidFill>
+              </a:defRPr>
+            </a:pPr>
+            <a:r>
+              <a:t>Cross-sectional, observational study with unmeasured confounders</a:t>
+            </a:r>
+          </a:p>
+        </p:txBody>
+      </p:sp>
+      <p:sp>
+        <p:nvSpPr>
+          <p:cNvPr id="8" name="TextBox 7"/>
+          <p:cNvSpPr txBox="1"/>
+          <p:nvPr/>
+        </p:nvSpPr>
+        <p:spPr>
+          <a:xfrm>
+            <a:off x="731520" y="2322576"/>
+            <a:ext cx="2743200" cy="320040"/>
+          </a:xfrm>
+          <a:prstGeom prst="rect">
+            <a:avLst/>
+          </a:prstGeom>
+          <a:noFill/>
+        </p:spPr>
+        <p:txBody>
+          <a:bodyPr wrap="square">
+            <a:spAutoFit/>
+          </a:bodyPr>
+          <a:lstStyle/>
+          <a:p>
+            <a:pPr algn="l">
+              <a:defRPr sz="1400" b="1">
+                <a:solidFill>
+                  <a:srgbClr val="F0883E"/>
+                </a:solidFill>
+              </a:defRPr>
+            </a:pPr>
+            <a:r>
+              <a:t>Census tract mismatch</a:t>
+            </a:r>
+          </a:p>
+        </p:txBody>
+      </p:sp>
+      <p:sp>
+        <p:nvSpPr>
+          <p:cNvPr id="9" name="TextBox 8"/>
+          <p:cNvSpPr txBox="1"/>
+          <p:nvPr/>
+        </p:nvSpPr>
+        <p:spPr>
+          <a:xfrm>
+            <a:off x="3657600" y="2322576"/>
+            <a:ext cx="8229600" cy="320040"/>
+          </a:xfrm>
+          <a:prstGeom prst="rect">
+            <a:avLst/>
+          </a:prstGeom>
+          <a:noFill/>
+        </p:spPr>
+        <p:txBody>
+          <a:bodyPr wrap="square">
+            <a:spAutoFit/>
+          </a:bodyPr>
+          <a:lstStyle/>
+          <a:p>
+            <a:pPr algn="l">
+              <a:defRPr sz="1300" b="0">
+                <a:solidFill>
+                  <a:srgbClr val="FFFFFF"/>
+                </a:solidFill>
+              </a:defRPr>
+            </a:pPr>
+            <a:r>
+              <a:t>USDA (2010) vs PLACES (2020) tracts; ~85-95% match, high-growth metros lose more</a:t>
+            </a:r>
+          </a:p>
+        </p:txBody>
+      </p:sp>
+      <p:sp>
+        <p:nvSpPr>
+          <p:cNvPr id="10" name="TextBox 9"/>
+          <p:cNvSpPr txBox="1"/>
+          <p:nvPr/>
+        </p:nvSpPr>
+        <p:spPr>
+          <a:xfrm>
+            <a:off x="731520" y="2889504"/>
+            <a:ext cx="2743200" cy="320040"/>
+          </a:xfrm>
+          <a:prstGeom prst="rect">
+            <a:avLst/>
+          </a:prstGeom>
+          <a:noFill/>
+        </p:spPr>
+        <p:txBody>
+          <a:bodyPr wrap="square">
+            <a:spAutoFit/>
+          </a:bodyPr>
+          <a:lstStyle/>
+          <a:p>
+            <a:pPr algn="l">
+              <a:defRPr sz="1400" b="1">
+                <a:solidFill>
+                  <a:srgbClr val="F0883E"/>
+                </a:solidFill>
+              </a:defRPr>
+            </a:pPr>
+            <a:r>
+              <a:t>Race classification</a:t>
+            </a:r>
+          </a:p>
+        </p:txBody>
+      </p:sp>
+      <p:sp>
+        <p:nvSpPr>
+          <p:cNvPr id="11" name="TextBox 10"/>
+          <p:cNvSpPr txBox="1"/>
+          <p:nvPr/>
+        </p:nvSpPr>
+        <p:spPr>
+          <a:xfrm>
+            <a:off x="3657600" y="2889504"/>
+            <a:ext cx="8229600" cy="320040"/>
+          </a:xfrm>
+          <a:prstGeom prst="rect">
+            <a:avLst/>
+          </a:prstGeom>
+          <a:noFill/>
+        </p:spPr>
+        <p:txBody>
+          <a:bodyPr wrap="square">
+            <a:spAutoFit/>
+          </a:bodyPr>
+          <a:lstStyle/>
+          <a:p>
+            <a:pPr algn="l">
+              <a:defRPr sz="1300" b="0">
+                <a:solidFill>
+                  <a:srgbClr val="FFFFFF"/>
+                </a:solidFill>
+              </a:defRPr>
+            </a:pPr>
+            <a:r>
+              <a:t>40% plurality among White/Black/Hispanic only; erases Asian, Native, multiracial communities</a:t>
+            </a:r>
+          </a:p>
+        </p:txBody>
+      </p:sp>
+      <p:sp>
+        <p:nvSpPr>
+          <p:cNvPr id="12" name="TextBox 11"/>
+          <p:cNvSpPr txBox="1"/>
+          <p:nvPr/>
+        </p:nvSpPr>
+        <p:spPr>
+          <a:xfrm>
+            <a:off x="731520" y="3456432"/>
+            <a:ext cx="2743200" cy="320040"/>
+          </a:xfrm>
+          <a:prstGeom prst="rect">
+            <a:avLst/>
+          </a:prstGeom>
+          <a:noFill/>
+        </p:spPr>
+        <p:txBody>
+          <a:bodyPr wrap="square">
+            <a:spAutoFit/>
+          </a:bodyPr>
+          <a:lstStyle/>
+          <a:p>
+            <a:pPr algn="l">
+              <a:defRPr sz="1400" b="1">
+                <a:solidFill>
+                  <a:srgbClr val="F0883E"/>
+                </a:solidFill>
+              </a:defRPr>
+            </a:pPr>
+            <a:r>
+              <a:t>Spatial autocorrelation</a:t>
+            </a:r>
+          </a:p>
+        </p:txBody>
+      </p:sp>
+      <p:sp>
+        <p:nvSpPr>
+          <p:cNvPr id="13" name="TextBox 12"/>
+          <p:cNvSpPr txBox="1"/>
+          <p:nvPr/>
+        </p:nvSpPr>
+        <p:spPr>
+          <a:xfrm>
+            <a:off x="3657600" y="3456432"/>
+            <a:ext cx="8229600" cy="320040"/>
+          </a:xfrm>
+          <a:prstGeom prst="rect">
+            <a:avLst/>
+          </a:prstGeom>
+          <a:noFill/>
+        </p:spPr>
+        <p:txBody>
+          <a:bodyPr wrap="square">
+            <a:spAutoFit/>
+          </a:bodyPr>
+          <a:lstStyle/>
+          <a:p>
+            <a:pPr algn="l">
+              <a:defRPr sz="1300" b="0">
+                <a:solidFill>
+                  <a:srgbClr val="FFFFFF"/>
+                </a:solidFill>
+              </a:defRPr>
+            </a:pPr>
+            <a:r>
+              <a:t>Neighboring tracts are correlated → inflated effective sample size → p-values too small</a:t>
+            </a:r>
+          </a:p>
+        </p:txBody>
+      </p:sp>
+      <p:sp>
+        <p:nvSpPr>
+          <p:cNvPr id="14" name="TextBox 13"/>
+          <p:cNvSpPr txBox="1"/>
+          <p:nvPr/>
+        </p:nvSpPr>
+        <p:spPr>
+          <a:xfrm>
+            <a:off x="731520" y="4023360"/>
+            <a:ext cx="2743200" cy="320040"/>
+          </a:xfrm>
+          <a:prstGeom prst="rect">
+            <a:avLst/>
+          </a:prstGeom>
+          <a:noFill/>
+        </p:spPr>
+        <p:txBody>
+          <a:bodyPr wrap="square">
+            <a:spAutoFit/>
+          </a:bodyPr>
+          <a:lstStyle/>
+          <a:p>
+            <a:pPr algn="l">
+              <a:defRPr sz="1400" b="1">
+                <a:solidFill>
+                  <a:srgbClr val="F0883E"/>
+                </a:solidFill>
+              </a:defRPr>
+            </a:pPr>
+            <a:r>
+              <a:t>Multiple comparisons</a:t>
+            </a:r>
+          </a:p>
+        </p:txBody>
+      </p:sp>
+      <p:sp>
+        <p:nvSpPr>
+          <p:cNvPr id="15" name="TextBox 14"/>
+          <p:cNvSpPr txBox="1"/>
+          <p:nvPr/>
+        </p:nvSpPr>
+        <p:spPr>
+          <a:xfrm>
+            <a:off x="3657600" y="4023360"/>
+            <a:ext cx="8229600" cy="320040"/>
+          </a:xfrm>
+          <a:prstGeom prst="rect">
+            <a:avLst/>
+          </a:prstGeom>
+          <a:noFill/>
+        </p:spPr>
+        <p:txBody>
+          <a:bodyPr wrap="square">
+            <a:spAutoFit/>
+          </a:bodyPr>
+          <a:lstStyle/>
+          <a:p>
+            <a:pPr algn="l">
+              <a:defRPr sz="1300" b="0">
+                <a:solidFill>
+                  <a:srgbClr val="FFFFFF"/>
+                </a:solidFill>
+              </a:defRPr>
+            </a:pPr>
+            <a:r>
+              <a:t>~15 tests without FDR correction; family-wise error rate ~54%</a:t>
+            </a:r>
+          </a:p>
+        </p:txBody>
+      </p:sp>
+      <p:sp>
+        <p:nvSpPr>
+          <p:cNvPr id="16" name="TextBox 15"/>
+          <p:cNvSpPr txBox="1"/>
+          <p:nvPr/>
+        </p:nvSpPr>
+        <p:spPr>
+          <a:xfrm>
+            <a:off x="731520" y="4590288"/>
+            <a:ext cx="2743200" cy="320040"/>
+          </a:xfrm>
+          <a:prstGeom prst="rect">
+            <a:avLst/>
+          </a:prstGeom>
+          <a:noFill/>
+        </p:spPr>
+        <p:txBody>
+          <a:bodyPr wrap="square">
+            <a:spAutoFit/>
+          </a:bodyPr>
+          <a:lstStyle/>
+          <a:p>
+            <a:pPr algn="l">
+              <a:defRPr sz="1400" b="1">
+                <a:solidFill>
+                  <a:srgbClr val="F0883E"/>
+                </a:solidFill>
+              </a:defRPr>
+            </a:pPr>
+            <a:r>
+              <a:t>No population weighting</a:t>
+            </a:r>
+          </a:p>
+        </p:txBody>
+      </p:sp>
+      <p:sp>
+        <p:nvSpPr>
+          <p:cNvPr id="17" name="TextBox 16"/>
+          <p:cNvSpPr txBox="1"/>
+          <p:nvPr/>
+        </p:nvSpPr>
+        <p:spPr>
+          <a:xfrm>
+            <a:off x="3657600" y="4590288"/>
+            <a:ext cx="8229600" cy="320040"/>
+          </a:xfrm>
+          <a:prstGeom prst="rect">
+            <a:avLst/>
+          </a:prstGeom>
+          <a:noFill/>
+        </p:spPr>
+        <p:txBody>
+          <a:bodyPr wrap="square">
+            <a:spAutoFit/>
+          </a:bodyPr>
+          <a:lstStyle/>
+          <a:p>
+            <a:pPr algn="l">
+              <a:defRPr sz="1300" b="0">
+                <a:solidFill>
+                  <a:srgbClr val="FFFFFF"/>
+                </a:solidFill>
+              </a:defRPr>
+            </a:pPr>
+            <a:r>
+              <a:t>Rural tracts (1,500 people) weighted equally with urban tracts (7,500)</a:t>
+            </a:r>
+          </a:p>
+        </p:txBody>
+      </p:sp>
+      <p:sp>
+        <p:nvSpPr>
+          <p:cNvPr id="18" name="TextBox 17"/>
+          <p:cNvSpPr txBox="1"/>
+          <p:nvPr/>
+        </p:nvSpPr>
+        <p:spPr>
+          <a:xfrm>
+            <a:off x="731520" y="5157216"/>
+            <a:ext cx="2743200" cy="320040"/>
+          </a:xfrm>
+          <a:prstGeom prst="rect">
+            <a:avLst/>
+          </a:prstGeom>
+          <a:noFill/>
+        </p:spPr>
+        <p:txBody>
+          <a:bodyPr wrap="square">
+            <a:spAutoFit/>
+          </a:bodyPr>
+          <a:lstStyle/>
+          <a:p>
+            <a:pPr algn="l">
+              <a:defRPr sz="1400" b="1">
+                <a:solidFill>
+                  <a:srgbClr val="F0883E"/>
+                </a:solidFill>
+              </a:defRPr>
+            </a:pPr>
+            <a:r>
+              <a:t>Modeled data</a:t>
+            </a:r>
+          </a:p>
+        </p:txBody>
+      </p:sp>
+      <p:sp>
+        <p:nvSpPr>
+          <p:cNvPr id="19" name="TextBox 18"/>
+          <p:cNvSpPr txBox="1"/>
+          <p:nvPr/>
+        </p:nvSpPr>
+        <p:spPr>
+          <a:xfrm>
+            <a:off x="3657600" y="5157216"/>
+            <a:ext cx="8229600" cy="320040"/>
+          </a:xfrm>
+          <a:prstGeom prst="rect">
+            <a:avLst/>
+          </a:prstGeom>
+          <a:noFill/>
+        </p:spPr>
+        <p:txBody>
+          <a:bodyPr wrap="square">
+            <a:spAutoFit/>
+          </a:bodyPr>
+          <a:lstStyle/>
+          <a:p>
+            <a:pPr algn="l">
+              <a:defRPr sz="1300" b="0">
+                <a:solidFill>
+                  <a:srgbClr val="FFFFFF"/>
+                </a:solidFill>
+              </a:defRPr>
+            </a:pPr>
+            <a:r>
+              <a:t>CDC PLACES uses small-area estimation, not direct measurement</a:t>
             </a:r>
           </a:p>
         </p:txBody>
@@ -4207,7 +4502,7 @@
               </a:defRPr>
             </a:pPr>
             <a:r>
-              <a:t>Limitations &amp; Ethical Considerations</a:t>
+              <a:t>Conclusion: Target Places, Not Just People</a:t>
             </a:r>
           </a:p>
         </p:txBody>
@@ -4221,7 +4516,7 @@
         <p:spPr>
           <a:xfrm>
             <a:off x="731520" y="1005840"/>
-            <a:ext cx="10515600" cy="502920"/>
+            <a:ext cx="10058400" cy="1097280"/>
           </a:xfrm>
           <a:prstGeom prst="rect">
             <a:avLst/>
@@ -4235,14 +4530,22 @@
           <a:lstStyle/>
           <a:p>
             <a:pPr algn="l">
-              <a:defRPr sz="1300" b="0">
-                <a:solidFill>
-                  <a:srgbClr val="FFFFFF"/>
-                </a:solidFill>
-              </a:defRPr>
-            </a:pPr>
-            <a:r>
-              <a:t>  Ecological fallacy — tract-level data, not individual-level. We cannot infer personal risk.</a:t>
+              <a:defRPr sz="2000" b="0">
+                <a:solidFill>
+                  <a:srgbClr val="F1C40F"/>
+                </a:solidFill>
+              </a:defRPr>
+            </a:pPr>
+            <a:r>
+              <a:t>These findings reframe obesity and diabetes from personal failings to</a:t>
+            </a:r>
+            <a:br/>
+            <a:r>
+              <a:t>systemic outcomes. Food access, income, healthcare availability, and race</a:t>
+            </a:r>
+            <a:br/>
+            <a:r>
+              <a:t>compound geographically to create zones of health disadvantage.</a:t>
             </a:r>
           </a:p>
         </p:txBody>
@@ -4255,8 +4558,8 @@
         </p:nvSpPr>
         <p:spPr>
           <a:xfrm>
-            <a:off x="731520" y="1554480"/>
-            <a:ext cx="10515600" cy="502920"/>
+            <a:off x="731520" y="2560320"/>
+            <a:ext cx="10058400" cy="365760"/>
           </a:xfrm>
           <a:prstGeom prst="rect">
             <a:avLst/>
@@ -4270,14 +4573,14 @@
           <a:lstStyle/>
           <a:p>
             <a:pPr algn="l">
-              <a:defRPr sz="1300" b="0">
+              <a:defRPr sz="2000" b="1">
                 <a:solidFill>
                   <a:srgbClr val="FFFFFF"/>
                 </a:solidFill>
               </a:defRPr>
             </a:pPr>
             <a:r>
-              <a:t>  Correlation, not causation — observational study with unmeasured confounders.</a:t>
+              <a:t>Policy Recommendations:</a:t>
             </a:r>
           </a:p>
         </p:txBody>
@@ -4290,8 +4593,8 @@
         </p:nvSpPr>
         <p:spPr>
           <a:xfrm>
-            <a:off x="731520" y="2103120"/>
-            <a:ext cx="10515600" cy="502920"/>
+            <a:off x="731520" y="3017520"/>
+            <a:ext cx="10058400" cy="1828800"/>
           </a:xfrm>
           <a:prstGeom prst="rect">
             <a:avLst/>
@@ -4304,15 +4607,63 @@
           </a:bodyPr>
           <a:lstStyle/>
           <a:p>
-            <a:pPr algn="l">
-              <a:defRPr sz="1300" b="0">
+            <a:pPr>
+              <a:spcAft>
+                <a:spcPts val="600"/>
+              </a:spcAft>
+              <a:defRPr sz="1700">
                 <a:solidFill>
                   <a:srgbClr val="FFFFFF"/>
                 </a:solidFill>
               </a:defRPr>
             </a:pPr>
             <a:r>
-              <a:t>  Census tract mismatch — USDA (2010) vs PLACES (2020) tracts; ~85-95% match rate.</a:t>
+              <a:t>Bring grocery stores and fresh food access to USDA-classified food deserts</a:t>
+            </a:r>
+          </a:p>
+          <a:p>
+            <a:pPr>
+              <a:spcAft>
+                <a:spcPts val="600"/>
+              </a:spcAft>
+              <a:defRPr sz="1700">
+                <a:solidFill>
+                  <a:srgbClr val="FFFFFF"/>
+                </a:solidFill>
+              </a:defRPr>
+            </a:pPr>
+            <a:r>
+              <a:t>Expand Medicaid and community health centers in HRSA shortage areas</a:t>
+            </a:r>
+          </a:p>
+          <a:p>
+            <a:pPr>
+              <a:spcAft>
+                <a:spcPts val="600"/>
+              </a:spcAft>
+              <a:defRPr sz="1700">
+                <a:solidFill>
+                  <a:srgbClr val="FFFFFF"/>
+                </a:solidFill>
+              </a:defRPr>
+            </a:pPr>
+            <a:r>
+              <a:t>Invest in education — the #1 predictor of life expectancy (β = +1.31)</a:t>
+            </a:r>
+          </a:p>
+          <a:p>
+            <a:pPr>
+              <a:spcAft>
+                <a:spcPts val="600"/>
+              </a:spcAft>
+              <a:defRPr sz="1700">
+                <a:solidFill>
+                  <a:srgbClr val="FFFFFF"/>
+                </a:solidFill>
+              </a:defRPr>
+            </a:pPr>
+            <a:r>
+              <a:t>Target the worst-HDI tracts directly — they are identifiable in our data</a:t>
             </a:r>
           </a:p>
         </p:txBody>
@@ -4325,8 +4676,8 @@
         </p:nvSpPr>
         <p:spPr>
           <a:xfrm>
-            <a:off x="731520" y="2651760"/>
-            <a:ext cx="10515600" cy="502920"/>
+            <a:off x="731520" y="4846320"/>
+            <a:ext cx="10058400" cy="365760"/>
           </a:xfrm>
           <a:prstGeom prst="rect">
             <a:avLst/>
@@ -4340,14 +4691,14 @@
           <a:lstStyle/>
           <a:p>
             <a:pPr algn="l">
-              <a:defRPr sz="1300" b="0">
+              <a:defRPr sz="1800" b="1">
                 <a:solidFill>
                   <a:srgbClr val="FFFFFF"/>
                 </a:solidFill>
               </a:defRPr>
             </a:pPr>
             <a:r>
-              <a:t>  Simplified race classification — 40% plurality threshold; erases Asian, Native, multiracial communities.</a:t>
+              <a:t>Future Work:</a:t>
             </a:r>
           </a:p>
         </p:txBody>
@@ -4360,8 +4711,8 @@
         </p:nvSpPr>
         <p:spPr>
           <a:xfrm>
-            <a:off x="731520" y="3200400"/>
-            <a:ext cx="10515600" cy="502920"/>
+            <a:off x="731520" y="5303520"/>
+            <a:ext cx="10058400" cy="1097280"/>
           </a:xfrm>
           <a:prstGeom prst="rect">
             <a:avLst/>
@@ -4374,120 +4725,48 @@
           </a:bodyPr>
           <a:lstStyle/>
           <a:p>
-            <a:pPr algn="l">
-              <a:defRPr sz="1300" b="0">
-                <a:solidFill>
-                  <a:srgbClr val="FFFFFF"/>
-                </a:solidFill>
-              </a:defRPr>
-            </a:pPr>
-            <a:r>
-              <a:t>  Spatial autocorrelation — neighboring tracts are correlated, inflating effective sample size.</a:t>
-            </a:r>
-          </a:p>
-        </p:txBody>
-      </p:sp>
-      <p:sp>
-        <p:nvSpPr>
-          <p:cNvPr id="8" name="TextBox 7"/>
-          <p:cNvSpPr txBox="1"/>
-          <p:nvPr/>
-        </p:nvSpPr>
-        <p:spPr>
-          <a:xfrm>
-            <a:off x="731520" y="3749040"/>
-            <a:ext cx="10515600" cy="502920"/>
-          </a:xfrm>
-          <a:prstGeom prst="rect">
-            <a:avLst/>
-          </a:prstGeom>
-          <a:noFill/>
-        </p:spPr>
-        <p:txBody>
-          <a:bodyPr wrap="square">
-            <a:spAutoFit/>
-          </a:bodyPr>
-          <a:lstStyle/>
-          <a:p>
-            <a:pPr algn="l">
-              <a:defRPr sz="1300" b="0">
-                <a:solidFill>
-                  <a:srgbClr val="FFFFFF"/>
-                </a:solidFill>
-              </a:defRPr>
-            </a:pPr>
-            <a:r>
-              <a:t>  Multiple comparisons — ~15 tests without correction; individual p-values are anti-conservative.</a:t>
-            </a:r>
-          </a:p>
-        </p:txBody>
-      </p:sp>
-      <p:sp>
-        <p:nvSpPr>
-          <p:cNvPr id="9" name="TextBox 8"/>
-          <p:cNvSpPr txBox="1"/>
-          <p:nvPr/>
-        </p:nvSpPr>
-        <p:spPr>
-          <a:xfrm>
-            <a:off x="731520" y="4297680"/>
-            <a:ext cx="10515600" cy="502920"/>
-          </a:xfrm>
-          <a:prstGeom prst="rect">
-            <a:avLst/>
-          </a:prstGeom>
-          <a:noFill/>
-        </p:spPr>
-        <p:txBody>
-          <a:bodyPr wrap="square">
-            <a:spAutoFit/>
-          </a:bodyPr>
-          <a:lstStyle/>
-          <a:p>
-            <a:pPr algn="l">
-              <a:defRPr sz="1300" b="0">
-                <a:solidFill>
-                  <a:srgbClr val="FFFFFF"/>
-                </a:solidFill>
-              </a:defRPr>
-            </a:pPr>
-            <a:r>
-              <a:t>  No population weighting — rural and urban tracts weighted equally.</a:t>
-            </a:r>
-          </a:p>
-        </p:txBody>
-      </p:sp>
-      <p:sp>
-        <p:nvSpPr>
-          <p:cNvPr id="10" name="TextBox 9"/>
-          <p:cNvSpPr txBox="1"/>
-          <p:nvPr/>
-        </p:nvSpPr>
-        <p:spPr>
-          <a:xfrm>
-            <a:off x="731520" y="4846320"/>
-            <a:ext cx="10515600" cy="502920"/>
-          </a:xfrm>
-          <a:prstGeom prst="rect">
-            <a:avLst/>
-          </a:prstGeom>
-          <a:noFill/>
-        </p:spPr>
-        <p:txBody>
-          <a:bodyPr wrap="square">
-            <a:spAutoFit/>
-          </a:bodyPr>
-          <a:lstStyle/>
-          <a:p>
-            <a:pPr algn="l">
-              <a:defRPr sz="1300" b="0">
-                <a:solidFill>
-                  <a:srgbClr val="FFFFFF"/>
-                </a:solidFill>
-              </a:defRPr>
-            </a:pPr>
-            <a:r>
-              <a:t>  Self-reported/modeled data — CDC PLACES uses small-area estimation, not direct measurement.</a:t>
+            <a:pPr>
+              <a:spcAft>
+                <a:spcPts val="600"/>
+              </a:spcAft>
+              <a:defRPr sz="1500">
+                <a:solidFill>
+                  <a:srgbClr val="8B949E"/>
+                </a:solidFill>
+              </a:defRPr>
+            </a:pPr>
+            <a:r>
+              <a:t>Validate with individual-level NHANES data</a:t>
+            </a:r>
+          </a:p>
+          <a:p>
+            <a:pPr>
+              <a:spcAft>
+                <a:spcPts val="600"/>
+              </a:spcAft>
+              <a:defRPr sz="1500">
+                <a:solidFill>
+                  <a:srgbClr val="8B949E"/>
+                </a:solidFill>
+              </a:defRPr>
+            </a:pPr>
+            <a:r>
+              <a:t>Spatial regression models (Moran's I, spatial lag) to account for clustering</a:t>
+            </a:r>
+          </a:p>
+          <a:p>
+            <a:pPr>
+              <a:spcAft>
+                <a:spcPts val="600"/>
+              </a:spcAft>
+              <a:defRPr sz="1500">
+                <a:solidFill>
+                  <a:srgbClr val="8B949E"/>
+                </a:solidFill>
+              </a:defRPr>
+            </a:pPr>
+            <a:r>
+              <a:t>Temporal analysis: did food desert tracts fare worse during COVID-19?</a:t>
             </a:r>
           </a:p>
         </p:txBody>
@@ -4526,8 +4805,8 @@
         </p:nvSpPr>
         <p:spPr>
           <a:xfrm>
-            <a:off x="731520" y="274320"/>
-            <a:ext cx="10058400" cy="457200"/>
+            <a:off x="914400" y="1645920"/>
+            <a:ext cx="10058400" cy="731520"/>
           </a:xfrm>
           <a:prstGeom prst="rect">
             <a:avLst/>
@@ -4540,15 +4819,15 @@
           </a:bodyPr>
           <a:lstStyle/>
           <a:p>
-            <a:pPr algn="l">
-              <a:defRPr sz="2800" b="1">
+            <a:pPr algn="ctr">
+              <a:defRPr sz="4400" b="1">
                 <a:solidFill>
                   <a:srgbClr val="FFFFFF"/>
                 </a:solidFill>
               </a:defRPr>
             </a:pPr>
             <a:r>
-              <a:t>Conclusion &amp; Policy Implications</a:t>
+              <a:t>Thank You</a:t>
             </a:r>
           </a:p>
         </p:txBody>
@@ -4561,8 +4840,8 @@
         </p:nvSpPr>
         <p:spPr>
           <a:xfrm>
-            <a:off x="731520" y="1097280"/>
-            <a:ext cx="10058400" cy="1371600"/>
+            <a:off x="914400" y="2743200"/>
+            <a:ext cx="10058400" cy="548640"/>
           </a:xfrm>
           <a:prstGeom prst="rect">
             <a:avLst/>
@@ -4575,23 +4854,15 @@
           </a:bodyPr>
           <a:lstStyle/>
           <a:p>
-            <a:pPr algn="l">
-              <a:defRPr sz="1800" b="0">
-                <a:solidFill>
-                  <a:srgbClr val="F1C40F"/>
-                </a:solidFill>
-              </a:defRPr>
-            </a:pPr>
-            <a:r>
-              <a:t>These findings reframe obesity and diabetes from personal failings to systemic</a:t>
-            </a:r>
-            <a:br/>
-            <a:r>
-              <a:t>outcomes. Food access, income, healthcare availability, and race compound</a:t>
-            </a:r>
-            <a:br/>
-            <a:r>
-              <a:t>geographically to create zones of health disadvantage.</a:t>
+            <a:pPr algn="ctr">
+              <a:defRPr sz="2200" b="0">
+                <a:solidFill>
+                  <a:srgbClr val="1F6FEB"/>
+                </a:solidFill>
+              </a:defRPr>
+            </a:pPr>
+            <a:r>
+              <a:t>Team 2Kim  |  Jimmy + Alice</a:t>
             </a:r>
           </a:p>
         </p:txBody>
@@ -4604,8 +4875,8 @@
         </p:nvSpPr>
         <p:spPr>
           <a:xfrm>
-            <a:off x="731520" y="2743200"/>
-            <a:ext cx="10058400" cy="365760"/>
+            <a:off x="914400" y="3474720"/>
+            <a:ext cx="10058400" cy="731520"/>
           </a:xfrm>
           <a:prstGeom prst="rect">
             <a:avLst/>
@@ -4618,15 +4889,19 @@
           </a:bodyPr>
           <a:lstStyle/>
           <a:p>
-            <a:pPr algn="l">
-              <a:defRPr sz="2000" b="1">
-                <a:solidFill>
-                  <a:srgbClr val="FFFFFF"/>
-                </a:solidFill>
-              </a:defRPr>
-            </a:pPr>
-            <a:r>
-              <a:t>Policy Recommendations:</a:t>
+            <a:pPr algn="ctr">
+              <a:defRPr sz="1600" b="0">
+                <a:solidFill>
+                  <a:srgbClr val="8B949E"/>
+                </a:solidFill>
+              </a:defRPr>
+            </a:pPr>
+            <a:r>
+              <a:t>27,235 census tracts  |  5 federal datasets  |  4 analysis phases</a:t>
+            </a:r>
+            <a:br/>
+            <a:r>
+              <a:t>github.com/jimbo111/datathon-kims</a:t>
             </a:r>
           </a:p>
         </p:txBody>
@@ -4639,8 +4914,8 @@
         </p:nvSpPr>
         <p:spPr>
           <a:xfrm>
-            <a:off x="731520" y="3200400"/>
-            <a:ext cx="10058400" cy="2286000"/>
+            <a:off x="914400" y="4754880"/>
+            <a:ext cx="10058400" cy="914400"/>
           </a:xfrm>
           <a:prstGeom prst="rect">
             <a:avLst/>
@@ -4653,336 +4928,19 @@
           </a:bodyPr>
           <a:lstStyle/>
           <a:p>
-            <a:pPr>
-              <a:spcAft>
-                <a:spcPts val="600"/>
-              </a:spcAft>
-              <a:defRPr sz="1600">
-                <a:solidFill>
-                  <a:srgbClr val="FFFFFF"/>
-                </a:solidFill>
-              </a:defRPr>
-            </a:pPr>
-            <a:r>
-              <a:t>Bring grocery stores and fresh food access to USDA-classified food deserts</a:t>
-            </a:r>
-          </a:p>
-          <a:p>
-            <a:pPr>
-              <a:spcAft>
-                <a:spcPts val="600"/>
-              </a:spcAft>
-              <a:defRPr sz="1600">
-                <a:solidFill>
-                  <a:srgbClr val="FFFFFF"/>
-                </a:solidFill>
-              </a:defRPr>
-            </a:pPr>
-            <a:r>
-              <a:t>Expand Medicaid and community health centers in HRSA shortage areas</a:t>
-            </a:r>
-          </a:p>
-          <a:p>
-            <a:pPr>
-              <a:spcAft>
-                <a:spcPts val="600"/>
-              </a:spcAft>
-              <a:defRPr sz="1600">
-                <a:solidFill>
-                  <a:srgbClr val="FFFFFF"/>
-                </a:solidFill>
-              </a:defRPr>
-            </a:pPr>
-            <a:r>
-              <a:t>Target interventions at places, not just people — the worst-HDI tracts are identifiable</a:t>
-            </a:r>
-          </a:p>
-          <a:p>
-            <a:pPr>
-              <a:spcAft>
-                <a:spcPts val="600"/>
-              </a:spcAft>
-              <a:defRPr sz="1600">
-                <a:solidFill>
-                  <a:srgbClr val="FFFFFF"/>
-                </a:solidFill>
-              </a:defRPr>
-            </a:pPr>
-            <a:r>
-              <a:t>Address structural determinants: education investment has the strongest life expectancy effect</a:t>
-            </a:r>
-          </a:p>
-        </p:txBody>
-      </p:sp>
-      <p:sp>
-        <p:nvSpPr>
-          <p:cNvPr id="6" name="TextBox 5"/>
-          <p:cNvSpPr txBox="1"/>
-          <p:nvPr/>
-        </p:nvSpPr>
-        <p:spPr>
-          <a:xfrm>
-            <a:off x="731520" y="5029200"/>
-            <a:ext cx="10058400" cy="365760"/>
-          </a:xfrm>
-          <a:prstGeom prst="rect">
-            <a:avLst/>
-          </a:prstGeom>
-          <a:noFill/>
-        </p:spPr>
-        <p:txBody>
-          <a:bodyPr wrap="square">
-            <a:spAutoFit/>
-          </a:bodyPr>
-          <a:lstStyle/>
-          <a:p>
-            <a:pPr algn="l">
-              <a:defRPr sz="2000" b="1">
-                <a:solidFill>
-                  <a:srgbClr val="FFFFFF"/>
-                </a:solidFill>
-              </a:defRPr>
-            </a:pPr>
-            <a:r>
-              <a:t>Future Work:</a:t>
-            </a:r>
-          </a:p>
-        </p:txBody>
-      </p:sp>
-      <p:sp>
-        <p:nvSpPr>
-          <p:cNvPr id="7" name="TextBox 6"/>
-          <p:cNvSpPr txBox="1"/>
-          <p:nvPr/>
-        </p:nvSpPr>
-        <p:spPr>
-          <a:xfrm>
-            <a:off x="731520" y="5486400"/>
-            <a:ext cx="10058400" cy="1371600"/>
-          </a:xfrm>
-          <a:prstGeom prst="rect">
-            <a:avLst/>
-          </a:prstGeom>
-          <a:noFill/>
-        </p:spPr>
-        <p:txBody>
-          <a:bodyPr wrap="square">
-            <a:spAutoFit/>
-          </a:bodyPr>
-          <a:lstStyle/>
-          <a:p>
-            <a:pPr>
-              <a:spcAft>
-                <a:spcPts val="600"/>
-              </a:spcAft>
-              <a:defRPr sz="1500">
-                <a:solidFill>
-                  <a:srgbClr val="8B949E"/>
-                </a:solidFill>
-              </a:defRPr>
-            </a:pPr>
-            <a:r>
-              <a:t>Link to individual-level NHANES data to validate ecological patterns</a:t>
-            </a:r>
-          </a:p>
-          <a:p>
-            <a:pPr>
-              <a:spcAft>
-                <a:spcPts val="600"/>
-              </a:spcAft>
-              <a:defRPr sz="1500">
-                <a:solidFill>
-                  <a:srgbClr val="8B949E"/>
-                </a:solidFill>
-              </a:defRPr>
-            </a:pPr>
-            <a:r>
-              <a:t>Spatial regression models to account for geographic clustering</a:t>
-            </a:r>
-          </a:p>
-          <a:p>
-            <a:pPr>
-              <a:spcAft>
-                <a:spcPts val="600"/>
-              </a:spcAft>
-              <a:defRPr sz="1500">
-                <a:solidFill>
-                  <a:srgbClr val="8B949E"/>
-                </a:solidFill>
-              </a:defRPr>
-            </a:pPr>
-            <a:r>
-              <a:t>Temporal analysis: did food desert tracts fare worse during COVID-19?</a:t>
-            </a:r>
-          </a:p>
-        </p:txBody>
-      </p:sp>
-    </p:spTree>
-  </p:cSld>
-  <p:clrMapOvr>
-    <a:masterClrMapping/>
-  </p:clrMapOvr>
-</p:sld>
-</file>
-
-<file path=ppt/slides/slide14.xml><?xml version="1.0" encoding="utf-8"?>
-<p:sld xmlns:a="http://schemas.openxmlformats.org/drawingml/2006/main" xmlns:p="http://schemas.openxmlformats.org/presentationml/2006/main" xmlns:r="http://schemas.openxmlformats.org/officeDocument/2006/relationships">
-  <p:cSld>
-    <p:bg>
-      <p:bgPr>
-        <a:solidFill>
-          <a:srgbClr val="0D1117"/>
-        </a:solidFill>
-        <a:effectLst/>
-      </p:bgPr>
-    </p:bg>
-    <p:spTree>
-      <p:nvGrpSpPr>
-        <p:cNvPr id="1" name=""/>
-        <p:cNvGrpSpPr/>
-        <p:nvPr/>
-      </p:nvGrpSpPr>
-      <p:grpSpPr/>
-      <p:sp>
-        <p:nvSpPr>
-          <p:cNvPr id="2" name="TextBox 1"/>
-          <p:cNvSpPr txBox="1"/>
-          <p:nvPr/>
-        </p:nvSpPr>
-        <p:spPr>
-          <a:xfrm>
-            <a:off x="914400" y="1828800"/>
-            <a:ext cx="10058400" cy="914400"/>
-          </a:xfrm>
-          <a:prstGeom prst="rect">
-            <a:avLst/>
-          </a:prstGeom>
-          <a:noFill/>
-        </p:spPr>
-        <p:txBody>
-          <a:bodyPr wrap="square">
-            <a:spAutoFit/>
-          </a:bodyPr>
-          <a:lstStyle/>
-          <a:p>
             <a:pPr algn="ctr">
-              <a:defRPr sz="4400" b="1">
-                <a:solidFill>
-                  <a:srgbClr val="FFFFFF"/>
-                </a:solidFill>
-              </a:defRPr>
-            </a:pPr>
-            <a:r>
-              <a:t>Thank You</a:t>
-            </a:r>
-          </a:p>
-        </p:txBody>
-      </p:sp>
-      <p:sp>
-        <p:nvSpPr>
-          <p:cNvPr id="3" name="TextBox 2"/>
-          <p:cNvSpPr txBox="1"/>
-          <p:nvPr/>
-        </p:nvSpPr>
-        <p:spPr>
-          <a:xfrm>
-            <a:off x="914400" y="3017520"/>
-            <a:ext cx="10058400" cy="731520"/>
-          </a:xfrm>
-          <a:prstGeom prst="rect">
-            <a:avLst/>
-          </a:prstGeom>
-          <a:noFill/>
-        </p:spPr>
-        <p:txBody>
-          <a:bodyPr wrap="square">
-            <a:spAutoFit/>
-          </a:bodyPr>
-          <a:lstStyle/>
-          <a:p>
-            <a:pPr algn="ctr">
-              <a:defRPr sz="2200" b="0">
-                <a:solidFill>
-                  <a:srgbClr val="1F6FEB"/>
-                </a:solidFill>
-              </a:defRPr>
-            </a:pPr>
-            <a:r>
-              <a:t>Team 2Kim  |  Jimmy + Alice</a:t>
-            </a:r>
-          </a:p>
-        </p:txBody>
-      </p:sp>
-      <p:sp>
-        <p:nvSpPr>
-          <p:cNvPr id="4" name="TextBox 3"/>
-          <p:cNvSpPr txBox="1"/>
-          <p:nvPr/>
-        </p:nvSpPr>
-        <p:spPr>
-          <a:xfrm>
-            <a:off x="914400" y="3931920"/>
-            <a:ext cx="10058400" cy="914400"/>
-          </a:xfrm>
-          <a:prstGeom prst="rect">
-            <a:avLst/>
-          </a:prstGeom>
-          <a:noFill/>
-        </p:spPr>
-        <p:txBody>
-          <a:bodyPr wrap="square">
-            <a:spAutoFit/>
-          </a:bodyPr>
-          <a:lstStyle/>
-          <a:p>
-            <a:pPr algn="ctr">
-              <a:defRPr sz="1600" b="0">
-                <a:solidFill>
-                  <a:srgbClr val="8B949E"/>
-                </a:solidFill>
-              </a:defRPr>
-            </a:pPr>
-            <a:r>
-              <a:t>27,235 census tracts  |  5 federal datasets  |  4 analysis phases</a:t>
+              <a:defRPr sz="2000" b="0">
+                <a:solidFill>
+                  <a:srgbClr val="F0883E"/>
+                </a:solidFill>
+              </a:defRPr>
+            </a:pPr>
+            <a:r>
+              <a:t>"We identified the tracts. The data is public.</a:t>
             </a:r>
             <a:br/>
             <a:r>
-              <a:t>github.com/jimbo111/datathon-kims</a:t>
-            </a:r>
-          </a:p>
-        </p:txBody>
-      </p:sp>
-      <p:sp>
-        <p:nvSpPr>
-          <p:cNvPr id="5" name="TextBox 4"/>
-          <p:cNvSpPr txBox="1"/>
-          <p:nvPr/>
-        </p:nvSpPr>
-        <p:spPr>
-          <a:xfrm>
-            <a:off x="914400" y="5303520"/>
-            <a:ext cx="10058400" cy="731520"/>
-          </a:xfrm>
-          <a:prstGeom prst="rect">
-            <a:avLst/>
-          </a:prstGeom>
-          <a:noFill/>
-        </p:spPr>
-        <p:txBody>
-          <a:bodyPr wrap="square">
-            <a:spAutoFit/>
-          </a:bodyPr>
-          <a:lstStyle/>
-          <a:p>
-            <a:pPr algn="ctr">
-              <a:defRPr sz="1800" b="0">
-                <a:solidFill>
-                  <a:srgbClr val="F0883E"/>
-                </a:solidFill>
-              </a:defRPr>
-            </a:pPr>
-            <a:r>
-              <a:t>"We identified the tracts. The data is public. The question is whether we act on it."</a:t>
+              <a:t>The question is whether we act on it."</a:t>
             </a:r>
           </a:p>
         </p:txBody>
@@ -5056,7 +5014,7 @@
         </p:nvSpPr>
         <p:spPr>
           <a:xfrm>
-            <a:off x="731520" y="1188720"/>
+            <a:off x="731520" y="1097280"/>
             <a:ext cx="10058400" cy="1097280"/>
           </a:xfrm>
           <a:prstGeom prst="rect">
@@ -5071,18 +5029,22 @@
           <a:lstStyle/>
           <a:p>
             <a:pPr algn="l">
-              <a:defRPr sz="2200" b="0">
+              <a:defRPr sz="2400" b="0">
                 <a:solidFill>
                   <a:srgbClr val="F1C40F"/>
                 </a:solidFill>
               </a:defRPr>
             </a:pPr>
             <a:r>
-              <a:t>Does living in a food desert independently predict higher rates of</a:t>
+              <a:t>Does living in a food desert independently predict higher</a:t>
             </a:r>
             <a:br/>
             <a:r>
-              <a:t>diabetes and obesity, even after controlling for income, insurance, and race?</a:t>
+              <a:t>diabetes and obesity, even after controlling for income,</a:t>
+            </a:r>
+            <a:br/>
+            <a:r>
+              <a:t>insurance, and race?</a:t>
             </a:r>
           </a:p>
         </p:txBody>
@@ -5117,7 +5079,7 @@
               </a:defRPr>
             </a:pPr>
             <a:r>
-              <a:t>Sub-questions:</a:t>
+              <a:t>Three sub-questions we test:</a:t>
             </a:r>
           </a:p>
         </p:txBody>
@@ -5155,7 +5117,7 @@
               </a:defRPr>
             </a:pPr>
             <a:r>
-              <a:t>1. How much of diabetes variance is explained by geography (between-county vs within)?</a:t>
+              <a:t>1. How much diabetes variance does geography explain? (variance decomposition)</a:t>
             </a:r>
           </a:p>
           <a:p>
@@ -5170,7 +5132,7 @@
               </a:defRPr>
             </a:pPr>
             <a:r>
-              <a:t>2. What is the life expectancy gap between richest and poorest tracts?</a:t>
+              <a:t>2. What is the life expectancy gap between rich and poor tracts? (regression)</a:t>
             </a:r>
           </a:p>
           <a:p>
@@ -5185,7 +5147,7 @@
               </a:defRPr>
             </a:pPr>
             <a:r>
-              <a:t>3. After controlling for income + food access, does race still predict diabetes?</a:t>
+              <a:t>3. Does race still predict diabetes after controlling for income + food access? (interaction model)</a:t>
             </a:r>
           </a:p>
         </p:txBody>
@@ -5198,8 +5160,8 @@
         </p:nvSpPr>
         <p:spPr>
           <a:xfrm>
-            <a:off x="731520" y="5029200"/>
-            <a:ext cx="10058400" cy="1097280"/>
+            <a:off x="731520" y="5303520"/>
+            <a:ext cx="10058400" cy="914400"/>
           </a:xfrm>
           <a:prstGeom prst="rect">
             <a:avLst/>
@@ -5220,15 +5182,11 @@
               </a:defRPr>
             </a:pPr>
             <a:r>
-              <a:t>Core thesis: Where you live — not just how you live — determines your health.</a:t>
+              <a:t>Thesis: Where you live — not just how you live — determines your health.</a:t>
             </a:r>
             <a:br/>
             <a:r>
-              <a:t>Food access, income, and race cluster geographically and compound into</a:t>
-            </a:r>
-            <a:br/>
-            <a:r>
-              <a:t>measurable chronic disease and mortality gaps.</a:t>
+              <a:t>Food access, income, and race compound geographically into measurable disease gaps.</a:t>
             </a:r>
           </a:p>
         </p:txBody>
@@ -5267,8 +5225,8 @@
         </p:nvSpPr>
         <p:spPr>
           <a:xfrm>
-            <a:off x="731520" y="365760"/>
-            <a:ext cx="10058400" cy="548640"/>
+            <a:off x="731520" y="274320"/>
+            <a:ext cx="10058400" cy="457200"/>
           </a:xfrm>
           <a:prstGeom prst="rect">
             <a:avLst/>
@@ -5289,7 +5247,7 @@
               </a:defRPr>
             </a:pPr>
             <a:r>
-              <a:t>Data: 5 Federal Datasets, 27,235 Census Tracts</a:t>
+              <a:t>Data: 5 Federal Datasets → 27,235 Census Tracts</a:t>
             </a:r>
           </a:p>
         </p:txBody>
@@ -5302,7 +5260,7 @@
         </p:nvSpPr>
         <p:spPr>
           <a:xfrm>
-            <a:off x="731520" y="1280160"/>
+            <a:off x="731520" y="1097280"/>
             <a:ext cx="10515600" cy="777240"/>
           </a:xfrm>
           <a:prstGeom prst="roundRect">
@@ -5355,7 +5313,7 @@
               </a:defRPr>
             </a:pPr>
             <a:r>
-              <a:t>Food desert flags by tract  —  ers.usda.gov</a:t>
+              <a:t>Food desert classification by tract (binary + continuous)  —  ers.usda.gov</a:t>
             </a:r>
           </a:p>
         </p:txBody>
@@ -5368,7 +5326,7 @@
         </p:nvSpPr>
         <p:spPr>
           <a:xfrm>
-            <a:off x="731520" y="2194560"/>
+            <a:off x="731520" y="2011680"/>
             <a:ext cx="10515600" cy="777240"/>
           </a:xfrm>
           <a:prstGeom prst="roundRect">
@@ -5421,7 +5379,7 @@
               </a:defRPr>
             </a:pPr>
             <a:r>
-              <a:t>Diabetes, obesity, BP, depression prevalence  —  data.cdc.gov</a:t>
+              <a:t>Diabetes, obesity, BP, depression, CHD, physical inactivity prevalence  —  data.cdc.gov</a:t>
             </a:r>
           </a:p>
         </p:txBody>
@@ -5434,7 +5392,7 @@
         </p:nvSpPr>
         <p:spPr>
           <a:xfrm>
-            <a:off x="731520" y="3108960"/>
+            <a:off x="731520" y="2926080"/>
             <a:ext cx="10515600" cy="777240"/>
           </a:xfrm>
           <a:prstGeom prst="roundRect">
@@ -5487,7 +5445,7 @@
               </a:defRPr>
             </a:pPr>
             <a:r>
-              <a:t>Income, poverty, race, education  —  Census Bureau API</a:t>
+              <a:t>Income, poverty rate, race/ethnicity, education by tract  —  Census Bureau API</a:t>
             </a:r>
           </a:p>
         </p:txBody>
@@ -5500,7 +5458,7 @@
         </p:nvSpPr>
         <p:spPr>
           <a:xfrm>
-            <a:off x="731520" y="4023360"/>
+            <a:off x="731520" y="3840480"/>
             <a:ext cx="10515600" cy="777240"/>
           </a:xfrm>
           <a:prstGeom prst="roundRect">
@@ -5553,7 +5511,7 @@
               </a:defRPr>
             </a:pPr>
             <a:r>
-              <a:t>Life expectancy at birth by tract  —  ftp.cdc.gov</a:t>
+              <a:t>Life expectancy at birth by tract (2010-2015)  —  ftp.cdc.gov</a:t>
             </a:r>
           </a:p>
         </p:txBody>
@@ -5566,7 +5524,7 @@
         </p:nvSpPr>
         <p:spPr>
           <a:xfrm>
-            <a:off x="731520" y="4937760"/>
+            <a:off x="731520" y="4754880"/>
             <a:ext cx="10515600" cy="777240"/>
           </a:xfrm>
           <a:prstGeom prst="roundRect">
@@ -5619,7 +5577,7 @@
               </a:defRPr>
             </a:pPr>
             <a:r>
-              <a:t>Primary care shortage designations  —  data.hrsa.gov</a:t>
+              <a:t>Primary care shortage area designations  —  data.hrsa.gov</a:t>
             </a:r>
           </a:p>
         </p:txBody>
@@ -5632,8 +5590,8 @@
         </p:nvSpPr>
         <p:spPr>
           <a:xfrm>
-            <a:off x="731520" y="5943600"/>
-            <a:ext cx="10058400" cy="457200"/>
+            <a:off x="731520" y="5852160"/>
+            <a:ext cx="10058400" cy="731520"/>
           </a:xfrm>
           <a:prstGeom prst="rect">
             <a:avLst/>
@@ -5647,14 +5605,18 @@
           <a:lstStyle/>
           <a:p>
             <a:pPr algn="l">
-              <a:defRPr sz="1400" b="0">
+              <a:defRPr sz="1300" b="0">
                 <a:solidFill>
                   <a:srgbClr val="8B949E"/>
                 </a:solidFill>
               </a:defRPr>
             </a:pPr>
             <a:r>
-              <a:t>All datasets joined on 11-digit FIPS census tract code</a:t>
+              <a:t>All joined on 11-digit FIPS census tract code. Merge quality: ~85-95% match rate.</a:t>
+            </a:r>
+            <a:br/>
+            <a:r>
+              <a:t>Cleaning: sentinel value filtering, group-quarters removal, FIPS standardization.</a:t>
             </a:r>
           </a:p>
         </p:txBody>
@@ -5693,8 +5655,8 @@
         </p:nvSpPr>
         <p:spPr>
           <a:xfrm>
-            <a:off x="731520" y="365760"/>
-            <a:ext cx="10058400" cy="548640"/>
+            <a:off x="731520" y="274320"/>
+            <a:ext cx="10058400" cy="457200"/>
           </a:xfrm>
           <a:prstGeom prst="rect">
             <a:avLst/>
@@ -5708,14 +5670,14 @@
           <a:lstStyle/>
           <a:p>
             <a:pPr algn="l">
-              <a:defRPr sz="3200" b="1">
+              <a:defRPr sz="2800" b="1">
                 <a:solidFill>
                   <a:srgbClr val="FFFFFF"/>
                 </a:solidFill>
               </a:defRPr>
             </a:pPr>
             <a:r>
-              <a:t>Methods</a:t>
+              <a:t>Methods at a Glance</a:t>
             </a:r>
           </a:p>
         </p:txBody>
@@ -5728,8 +5690,8 @@
         </p:nvSpPr>
         <p:spPr>
           <a:xfrm>
-            <a:off x="731520" y="1188720"/>
-            <a:ext cx="2743200" cy="365760"/>
+            <a:off x="731520" y="1005840"/>
+            <a:ext cx="3200400" cy="320040"/>
           </a:xfrm>
           <a:prstGeom prst="rect">
             <a:avLst/>
@@ -5743,14 +5705,14 @@
           <a:lstStyle/>
           <a:p>
             <a:pPr algn="l">
-              <a:defRPr sz="1600" b="1">
+              <a:defRPr sz="1500" b="1">
                 <a:solidFill>
                   <a:srgbClr val="1F6FEB"/>
                 </a:solidFill>
               </a:defRPr>
             </a:pPr>
             <a:r>
-              <a:t>Data Pipeline</a:t>
+              <a:t>OLS Regression</a:t>
             </a:r>
           </a:p>
         </p:txBody>
@@ -5763,8 +5725,8 @@
         </p:nvSpPr>
         <p:spPr>
           <a:xfrm>
-            <a:off x="3657600" y="1188720"/>
-            <a:ext cx="8229600" cy="640080"/>
+            <a:off x="4114800" y="1005840"/>
+            <a:ext cx="7772400" cy="320040"/>
           </a:xfrm>
           <a:prstGeom prst="rect">
             <a:avLst/>
@@ -5785,11 +5747,7 @@
               </a:defRPr>
             </a:pPr>
             <a:r>
-              <a:t>Download, clean, standardize 5 datasets; merge on FIPS;</a:t>
-            </a:r>
-            <a:br/>
-            <a:r>
-              <a:t>filter group-quarters tracts; compute derived variables</a:t>
+              <a:t>diabetes ~ food_desert + poverty + uninsured, with HC1 robust standard errors</a:t>
             </a:r>
           </a:p>
         </p:txBody>
@@ -5802,8 +5760,8 @@
         </p:nvSpPr>
         <p:spPr>
           <a:xfrm>
-            <a:off x="731520" y="1965960"/>
-            <a:ext cx="2743200" cy="365760"/>
+            <a:off x="731520" y="1664208"/>
+            <a:ext cx="3200400" cy="320040"/>
           </a:xfrm>
           <a:prstGeom prst="rect">
             <a:avLst/>
@@ -5817,14 +5775,14 @@
           <a:lstStyle/>
           <a:p>
             <a:pPr algn="l">
-              <a:defRPr sz="1600" b="1">
+              <a:defRPr sz="1500" b="1">
                 <a:solidFill>
                   <a:srgbClr val="1F6FEB"/>
                 </a:solidFill>
               </a:defRPr>
             </a:pPr>
             <a:r>
-              <a:t>OLS Regression</a:t>
+              <a:t>VIF Check</a:t>
             </a:r>
           </a:p>
         </p:txBody>
@@ -5837,8 +5795,8 @@
         </p:nvSpPr>
         <p:spPr>
           <a:xfrm>
-            <a:off x="3657600" y="1965960"/>
-            <a:ext cx="8229600" cy="640080"/>
+            <a:off x="4114800" y="1664208"/>
+            <a:ext cx="7772400" cy="320040"/>
           </a:xfrm>
           <a:prstGeom prst="rect">
             <a:avLst/>
@@ -5859,11 +5817,7 @@
               </a:defRPr>
             </a:pPr>
             <a:r>
-              <a:t>diabetes/obesity ~ food_desert + poverty + uninsured</a:t>
-            </a:r>
-            <a:br/>
-            <a:r>
-              <a:t>with HC1 robust standard errors; VIF multicollinearity check</a:t>
+              <a:t>Variance Inflation Factor to confirm no multicollinearity between predictors</a:t>
             </a:r>
           </a:p>
         </p:txBody>
@@ -5876,8 +5830,8 @@
         </p:nvSpPr>
         <p:spPr>
           <a:xfrm>
-            <a:off x="731520" y="2743200"/>
-            <a:ext cx="2743200" cy="365760"/>
+            <a:off x="731520" y="2322576"/>
+            <a:ext cx="3200400" cy="320040"/>
           </a:xfrm>
           <a:prstGeom prst="rect">
             <a:avLst/>
@@ -5891,7 +5845,7 @@
           <a:lstStyle/>
           <a:p>
             <a:pPr algn="l">
-              <a:defRPr sz="1600" b="1">
+              <a:defRPr sz="1500" b="1">
                 <a:solidFill>
                   <a:srgbClr val="1F6FEB"/>
                 </a:solidFill>
@@ -5911,8 +5865,8 @@
         </p:nvSpPr>
         <p:spPr>
           <a:xfrm>
-            <a:off x="3657600" y="2743200"/>
-            <a:ext cx="8229600" cy="640080"/>
+            <a:off x="4114800" y="2322576"/>
+            <a:ext cx="7772400" cy="320040"/>
           </a:xfrm>
           <a:prstGeom prst="rect">
             <a:avLst/>
@@ -5933,11 +5887,7 @@
               </a:defRPr>
             </a:pPr>
             <a:r>
-              <a:t>2x2 contingency table: food desert (yes/no) x diabetes (above/below median)</a:t>
-            </a:r>
-            <a:br/>
-            <a:r>
-              <a:t>Welch t-test for mean comparison</a:t>
+              <a:t>2x2 table (food desert yes/no × high/low diabetes) + Welch t-test for means</a:t>
             </a:r>
           </a:p>
         </p:txBody>
@@ -5950,8 +5900,8 @@
         </p:nvSpPr>
         <p:spPr>
           <a:xfrm>
-            <a:off x="731520" y="3520440"/>
-            <a:ext cx="2743200" cy="365760"/>
+            <a:off x="731520" y="2980944"/>
+            <a:ext cx="3200400" cy="320040"/>
           </a:xfrm>
           <a:prstGeom prst="rect">
             <a:avLst/>
@@ -5965,7 +5915,7 @@
           <a:lstStyle/>
           <a:p>
             <a:pPr algn="l">
-              <a:defRPr sz="1600" b="1">
+              <a:defRPr sz="1500" b="1">
                 <a:solidFill>
                   <a:srgbClr val="1F6FEB"/>
                 </a:solidFill>
@@ -5985,8 +5935,8 @@
         </p:nvSpPr>
         <p:spPr>
           <a:xfrm>
-            <a:off x="3657600" y="3520440"/>
-            <a:ext cx="8229600" cy="640080"/>
+            <a:off x="4114800" y="2980944"/>
+            <a:ext cx="7772400" cy="320040"/>
           </a:xfrm>
           <a:prstGeom prst="rect">
             <a:avLst/>
@@ -6007,11 +5957,7 @@
               </a:defRPr>
             </a:pPr>
             <a:r>
-              <a:t>Between-county vs within-county diabetes variance</a:t>
-            </a:r>
-            <a:br/>
-            <a:r>
-              <a:t>(weighted by tract count per county)</a:t>
+              <a:t>Between-county vs within-county diabetes variance, weighted by tract count</a:t>
             </a:r>
           </a:p>
         </p:txBody>
@@ -6024,8 +5970,8 @@
         </p:nvSpPr>
         <p:spPr>
           <a:xfrm>
-            <a:off x="731520" y="4297680"/>
-            <a:ext cx="2743200" cy="365760"/>
+            <a:off x="731520" y="3639311"/>
+            <a:ext cx="3200400" cy="320040"/>
           </a:xfrm>
           <a:prstGeom prst="rect">
             <a:avLst/>
@@ -6039,14 +5985,14 @@
           <a:lstStyle/>
           <a:p>
             <a:pPr algn="l">
-              <a:defRPr sz="1600" b="1">
+              <a:defRPr sz="1500" b="1">
                 <a:solidFill>
                   <a:srgbClr val="1F6FEB"/>
                 </a:solidFill>
               </a:defRPr>
             </a:pPr>
             <a:r>
-              <a:t>Interaction Model</a:t>
+              <a:t>Standardized Betas</a:t>
             </a:r>
           </a:p>
         </p:txBody>
@@ -6059,8 +6005,8 @@
         </p:nvSpPr>
         <p:spPr>
           <a:xfrm>
-            <a:off x="3657600" y="4297680"/>
-            <a:ext cx="8229600" cy="640080"/>
+            <a:off x="4114800" y="3639311"/>
+            <a:ext cx="7772400" cy="320040"/>
           </a:xfrm>
           <a:prstGeom prst="rect">
             <a:avLst/>
@@ -6081,11 +6027,7 @@
               </a:defRPr>
             </a:pPr>
             <a:r>
-              <a:t>diabetes ~ income x race + food_desert</a:t>
-            </a:r>
-            <a:br/>
-            <a:r>
-              <a:t>Tests if income's protective effect differs by race</a:t>
+              <a:t>Z-scored predictors → coefficients show relative importance for life expectancy</a:t>
             </a:r>
           </a:p>
         </p:txBody>
@@ -6098,8 +6040,8 @@
         </p:nvSpPr>
         <p:spPr>
           <a:xfrm>
-            <a:off x="731520" y="5074920"/>
-            <a:ext cx="2743200" cy="365760"/>
+            <a:off x="731520" y="4297679"/>
+            <a:ext cx="3200400" cy="320040"/>
           </a:xfrm>
           <a:prstGeom prst="rect">
             <a:avLst/>
@@ -6113,14 +6055,14 @@
           <a:lstStyle/>
           <a:p>
             <a:pPr algn="l">
-              <a:defRPr sz="1600" b="1">
+              <a:defRPr sz="1500" b="1">
                 <a:solidFill>
                   <a:srgbClr val="1F6FEB"/>
                 </a:solidFill>
               </a:defRPr>
             </a:pPr>
             <a:r>
-              <a:t>Health Disadvantage Index</a:t>
+              <a:t>Interaction Model</a:t>
             </a:r>
           </a:p>
         </p:txBody>
@@ -6133,8 +6075,8 @@
         </p:nvSpPr>
         <p:spPr>
           <a:xfrm>
-            <a:off x="3657600" y="5074920"/>
-            <a:ext cx="8229600" cy="640080"/>
+            <a:off x="4114800" y="4297679"/>
+            <a:ext cx="7772400" cy="320040"/>
           </a:xfrm>
           <a:prstGeom prst="rect">
             <a:avLst/>
@@ -6155,11 +6097,77 @@
               </a:defRPr>
             </a:pPr>
             <a:r>
-              <a:t>Equal-weighted z-score composite:</a:t>
-            </a:r>
-            <a:br/>
-            <a:r>
-              <a:t>food access + poverty + healthcare access</a:t>
+              <a:t>diabetes ~ income × race + food_desert — tests if income's effect differs by race</a:t>
+            </a:r>
+          </a:p>
+        </p:txBody>
+      </p:sp>
+      <p:sp>
+        <p:nvSpPr>
+          <p:cNvPr id="15" name="TextBox 14"/>
+          <p:cNvSpPr txBox="1"/>
+          <p:nvPr/>
+        </p:nvSpPr>
+        <p:spPr>
+          <a:xfrm>
+            <a:off x="731520" y="4956047"/>
+            <a:ext cx="3200400" cy="320040"/>
+          </a:xfrm>
+          <a:prstGeom prst="rect">
+            <a:avLst/>
+          </a:prstGeom>
+          <a:noFill/>
+        </p:spPr>
+        <p:txBody>
+          <a:bodyPr wrap="square">
+            <a:spAutoFit/>
+          </a:bodyPr>
+          <a:lstStyle/>
+          <a:p>
+            <a:pPr algn="l">
+              <a:defRPr sz="1500" b="1">
+                <a:solidFill>
+                  <a:srgbClr val="1F6FEB"/>
+                </a:solidFill>
+              </a:defRPr>
+            </a:pPr>
+            <a:r>
+              <a:t>Health Disadvantage Index</a:t>
+            </a:r>
+          </a:p>
+        </p:txBody>
+      </p:sp>
+      <p:sp>
+        <p:nvSpPr>
+          <p:cNvPr id="16" name="TextBox 15"/>
+          <p:cNvSpPr txBox="1"/>
+          <p:nvPr/>
+        </p:nvSpPr>
+        <p:spPr>
+          <a:xfrm>
+            <a:off x="4114800" y="4956047"/>
+            <a:ext cx="7772400" cy="320040"/>
+          </a:xfrm>
+          <a:prstGeom prst="rect">
+            <a:avLst/>
+          </a:prstGeom>
+          <a:noFill/>
+        </p:spPr>
+        <p:txBody>
+          <a:bodyPr wrap="square">
+            <a:spAutoFit/>
+          </a:bodyPr>
+          <a:lstStyle/>
+          <a:p>
+            <a:pPr algn="l">
+              <a:defRPr sz="1300" b="0">
+                <a:solidFill>
+                  <a:srgbClr val="8B949E"/>
+                </a:solidFill>
+              </a:defRPr>
+            </a:pPr>
+            <a:r>
+              <a:t>Equal-weighted z-score composite: food access + poverty + healthcare access</a:t>
             </a:r>
           </a:p>
         </p:txBody>
@@ -6198,7 +6206,7 @@
         </p:nvSpPr>
         <p:spPr>
           <a:xfrm>
-            <a:off x="731520" y="274320"/>
+            <a:off x="731520" y="182880"/>
             <a:ext cx="10058400" cy="457200"/>
           </a:xfrm>
           <a:prstGeom prst="rect">
@@ -6213,14 +6221,14 @@
           <a:lstStyle/>
           <a:p>
             <a:pPr algn="l">
-              <a:defRPr sz="2800" b="1">
+              <a:defRPr sz="2400" b="1">
                 <a:solidFill>
                   <a:srgbClr val="FFFFFF"/>
                 </a:solidFill>
               </a:defRPr>
             </a:pPr>
             <a:r>
-              <a:t>EDA: Food Desert vs Non-Food-Desert Tracts</a:t>
+              <a:t>EDA: Food Desert Tracts Have Worse Outcomes on Every Metric</a:t>
             </a:r>
           </a:p>
         </p:txBody>
@@ -6241,8 +6249,8 @@
         </p:blipFill>
         <p:spPr>
           <a:xfrm>
-            <a:off x="457200" y="914400"/>
-            <a:ext cx="11247120" cy="4754880"/>
+            <a:off x="274320" y="822960"/>
+            <a:ext cx="11430000" cy="4572000"/>
           </a:xfrm>
           <a:prstGeom prst="rect">
             <a:avLst/>
@@ -6257,8 +6265,8 @@
         </p:nvSpPr>
         <p:spPr>
           <a:xfrm>
-            <a:off x="731520" y="5852160"/>
-            <a:ext cx="10058400" cy="731520"/>
+            <a:off x="731520" y="5577840"/>
+            <a:ext cx="10058400" cy="914400"/>
           </a:xfrm>
           <a:prstGeom prst="rect">
             <a:avLst/>
@@ -6279,7 +6287,11 @@
               </a:defRPr>
             </a:pPr>
             <a:r>
-              <a:t>Food desert tracts show higher diabetes, obesity, and blood pressure — and lower life expectancy.</a:t>
+              <a:t>Food desert tracts show ~3.7pp higher diabetes, elevated obesity and blood pressure, and lower</a:t>
+            </a:r>
+            <a:br/>
+            <a:r>
+              <a:t>life expectancy. This pattern is consistent, not random — motivating the regression analysis below.</a:t>
             </a:r>
           </a:p>
         </p:txBody>
@@ -6318,7 +6330,7 @@
         </p:nvSpPr>
         <p:spPr>
           <a:xfrm>
-            <a:off x="731520" y="274320"/>
+            <a:off x="731520" y="182880"/>
             <a:ext cx="10058400" cy="457200"/>
           </a:xfrm>
           <a:prstGeom prst="rect">
@@ -6333,21 +6345,21 @@
           <a:lstStyle/>
           <a:p>
             <a:pPr algn="l">
-              <a:defRPr sz="2800" b="1">
+              <a:defRPr sz="2400" b="1">
                 <a:solidFill>
                   <a:srgbClr val="FFFFFF"/>
                 </a:solidFill>
               </a:defRPr>
             </a:pPr>
             <a:r>
-              <a:t>EDA: Correlation Matrix</a:t>
+              <a:t>EDA: Poverty, Food Deserts, and Race Cluster Together</a:t>
             </a:r>
           </a:p>
         </p:txBody>
       </p:sp>
       <p:pic>
         <p:nvPicPr>
-          <p:cNvPr id="3" name="Picture 2" descr="eda-correlation.png"/>
+          <p:cNvPr id="3" name="Picture 2" descr="eda-scatter.png"/>
           <p:cNvPicPr>
             <a:picLocks noChangeAspect="1"/>
           </p:cNvPicPr>
@@ -6361,8 +6373,8 @@
         </p:blipFill>
         <p:spPr>
           <a:xfrm>
-            <a:off x="1371600" y="914400"/>
-            <a:ext cx="9144000" cy="5029200"/>
+            <a:off x="274320" y="822960"/>
+            <a:ext cx="11430000" cy="4572000"/>
           </a:xfrm>
           <a:prstGeom prst="rect">
             <a:avLst/>
@@ -6377,8 +6389,8 @@
         </p:nvSpPr>
         <p:spPr>
           <a:xfrm>
-            <a:off x="731520" y="6035040"/>
-            <a:ext cx="10058400" cy="548640"/>
+            <a:off x="731520" y="5577840"/>
+            <a:ext cx="10058400" cy="914400"/>
           </a:xfrm>
           <a:prstGeom prst="rect">
             <a:avLst/>
@@ -6399,7 +6411,11 @@
               </a:defRPr>
             </a:pPr>
             <a:r>
-              <a:t>Poverty, food desert status, and physical inactivity strongly correlate with diabetes and obesity. Education correlates with better outcomes.</a:t>
+              <a:t>Left: Food desert tracts (red) cluster in the high-poverty, high-diabetes corner.</a:t>
+            </a:r>
+            <a:br/>
+            <a:r>
+              <a:t>Right: Majority-Black and -Hispanic tracts occupy the same region. The overlap is structural, not coincidental.</a:t>
             </a:r>
           </a:p>
         </p:txBody>
@@ -6438,8 +6454,8 @@
         </p:nvSpPr>
         <p:spPr>
           <a:xfrm>
-            <a:off x="731520" y="274320"/>
-            <a:ext cx="10058400" cy="457200"/>
+            <a:off x="731520" y="182880"/>
+            <a:ext cx="7315200" cy="457200"/>
           </a:xfrm>
           <a:prstGeom prst="rect">
             <a:avLst/>
@@ -6460,45 +6476,231 @@
               </a:defRPr>
             </a:pPr>
             <a:r>
-              <a:t>EDA: Poverty vs Diabetes by Food Desert Status &amp; Race</a:t>
-            </a:r>
-          </a:p>
-        </p:txBody>
-      </p:sp>
-      <p:pic>
-        <p:nvPicPr>
-          <p:cNvPr id="3" name="Picture 2" descr="eda-scatter.png"/>
-          <p:cNvPicPr>
-            <a:picLocks noChangeAspect="1"/>
-          </p:cNvPicPr>
-          <p:nvPr/>
-        </p:nvPicPr>
-        <p:blipFill>
-          <a:blip r:embed="rId2"/>
-          <a:stretch>
-            <a:fillRect/>
-          </a:stretch>
-        </p:blipFill>
-        <p:spPr>
-          <a:xfrm>
-            <a:off x="274320" y="914400"/>
-            <a:ext cx="11430000" cy="4754880"/>
-          </a:xfrm>
-          <a:prstGeom prst="rect">
-            <a:avLst/>
-          </a:prstGeom>
-        </p:spPr>
-      </p:pic>
-      <p:sp>
-        <p:nvSpPr>
-          <p:cNvPr id="4" name="TextBox 3"/>
+              <a:t>Finding 1: Food Deserts Independently Predict Diabetes</a:t>
+            </a:r>
+          </a:p>
+        </p:txBody>
+      </p:sp>
+      <p:sp>
+        <p:nvSpPr>
+          <p:cNvPr id="3" name="Rounded Rectangle 2"/>
+          <p:cNvSpPr/>
+          <p:nvPr/>
+        </p:nvSpPr>
+        <p:spPr>
+          <a:xfrm>
+            <a:off x="731520" y="914400"/>
+            <a:ext cx="3200400" cy="1280160"/>
+          </a:xfrm>
+          <a:prstGeom prst="roundRect">
+            <a:avLst/>
+          </a:prstGeom>
+          <a:solidFill>
+            <a:srgbClr val="161B22"/>
+          </a:solidFill>
+          <a:ln w="12700">
+            <a:solidFill>
+              <a:srgbClr val="30363D"/>
+            </a:solidFill>
+          </a:ln>
+        </p:spPr>
+        <p:style>
+          <a:lnRef idx="1">
+            <a:schemeClr val="accent1"/>
+          </a:lnRef>
+          <a:fillRef idx="3">
+            <a:schemeClr val="accent1"/>
+          </a:fillRef>
+          <a:effectRef idx="2">
+            <a:schemeClr val="accent1"/>
+          </a:effectRef>
+          <a:fontRef idx="minor">
+            <a:schemeClr val="lt1"/>
+          </a:fontRef>
+        </p:style>
+        <p:txBody>
+          <a:bodyPr rtlCol="0" anchor="ctr" wrap="square"/>
+          <a:lstStyle/>
+          <a:p>
+            <a:pPr algn="ctr">
+              <a:defRPr sz="2800" b="1">
+                <a:solidFill>
+                  <a:srgbClr val="2ECC71"/>
+                </a:solidFill>
+              </a:defRPr>
+            </a:pPr>
+            <a:r>
+              <a:t>5.45x</a:t>
+            </a:r>
+          </a:p>
+          <a:p>
+            <a:pPr algn="ctr">
+              <a:defRPr sz="1200">
+                <a:solidFill>
+                  <a:srgbClr val="8B949E"/>
+                </a:solidFill>
+              </a:defRPr>
+            </a:pPr>
+            <a:r>
+              <a:t>Ecological odds of above-median</a:t>
+            </a:r>
+            <a:br/>
+            <a:r>
+              <a:t>diabetes in food desert tracts</a:t>
+            </a:r>
+          </a:p>
+        </p:txBody>
+      </p:sp>
+      <p:sp>
+        <p:nvSpPr>
+          <p:cNvPr id="4" name="Rounded Rectangle 3"/>
+          <p:cNvSpPr/>
+          <p:nvPr/>
+        </p:nvSpPr>
+        <p:spPr>
+          <a:xfrm>
+            <a:off x="4297680" y="914400"/>
+            <a:ext cx="3200400" cy="1280160"/>
+          </a:xfrm>
+          <a:prstGeom prst="roundRect">
+            <a:avLst/>
+          </a:prstGeom>
+          <a:solidFill>
+            <a:srgbClr val="161B22"/>
+          </a:solidFill>
+          <a:ln w="12700">
+            <a:solidFill>
+              <a:srgbClr val="30363D"/>
+            </a:solidFill>
+          </a:ln>
+        </p:spPr>
+        <p:style>
+          <a:lnRef idx="1">
+            <a:schemeClr val="accent1"/>
+          </a:lnRef>
+          <a:fillRef idx="3">
+            <a:schemeClr val="accent1"/>
+          </a:fillRef>
+          <a:effectRef idx="2">
+            <a:schemeClr val="accent1"/>
+          </a:effectRef>
+          <a:fontRef idx="minor">
+            <a:schemeClr val="lt1"/>
+          </a:fontRef>
+        </p:style>
+        <p:txBody>
+          <a:bodyPr rtlCol="0" anchor="ctr" wrap="square"/>
+          <a:lstStyle/>
+          <a:p>
+            <a:pPr algn="ctr">
+              <a:defRPr sz="2800" b="1">
+                <a:solidFill>
+                  <a:srgbClr val="1F6FEB"/>
+                </a:solidFill>
+              </a:defRPr>
+            </a:pPr>
+            <a:r>
+              <a:t>R² = 0.50</a:t>
+            </a:r>
+          </a:p>
+          <a:p>
+            <a:pPr algn="ctr">
+              <a:defRPr sz="1200">
+                <a:solidFill>
+                  <a:srgbClr val="8B949E"/>
+                </a:solidFill>
+              </a:defRPr>
+            </a:pPr>
+            <a:r>
+              <a:t>Of diabetes variance explained</a:t>
+            </a:r>
+            <a:br/>
+            <a:r>
+              <a:t>by 3 predictors</a:t>
+            </a:r>
+          </a:p>
+        </p:txBody>
+      </p:sp>
+      <p:sp>
+        <p:nvSpPr>
+          <p:cNvPr id="5" name="Rounded Rectangle 4"/>
+          <p:cNvSpPr/>
+          <p:nvPr/>
+        </p:nvSpPr>
+        <p:spPr>
+          <a:xfrm>
+            <a:off x="7863840" y="914400"/>
+            <a:ext cx="3200400" cy="1280160"/>
+          </a:xfrm>
+          <a:prstGeom prst="roundRect">
+            <a:avLst/>
+          </a:prstGeom>
+          <a:solidFill>
+            <a:srgbClr val="161B22"/>
+          </a:solidFill>
+          <a:ln w="12700">
+            <a:solidFill>
+              <a:srgbClr val="30363D"/>
+            </a:solidFill>
+          </a:ln>
+        </p:spPr>
+        <p:style>
+          <a:lnRef idx="1">
+            <a:schemeClr val="accent1"/>
+          </a:lnRef>
+          <a:fillRef idx="3">
+            <a:schemeClr val="accent1"/>
+          </a:fillRef>
+          <a:effectRef idx="2">
+            <a:schemeClr val="accent1"/>
+          </a:effectRef>
+          <a:fontRef idx="minor">
+            <a:schemeClr val="lt1"/>
+          </a:fontRef>
+        </p:style>
+        <p:txBody>
+          <a:bodyPr rtlCol="0" anchor="ctr" wrap="square"/>
+          <a:lstStyle/>
+          <a:p>
+            <a:pPr algn="ctr">
+              <a:defRPr sz="2800" b="1">
+                <a:solidFill>
+                  <a:srgbClr val="F0883E"/>
+                </a:solidFill>
+              </a:defRPr>
+            </a:pPr>
+            <a:r>
+              <a:t>15.95%</a:t>
+            </a:r>
+          </a:p>
+          <a:p>
+            <a:pPr algn="ctr">
+              <a:defRPr sz="1200">
+                <a:solidFill>
+                  <a:srgbClr val="8B949E"/>
+                </a:solidFill>
+              </a:defRPr>
+            </a:pPr>
+            <a:r>
+              <a:t>Mean diabetes in food deserts</a:t>
+            </a:r>
+            <a:br/>
+            <a:r>
+              <a:t>vs 12.28% in non-deserts</a:t>
+            </a:r>
+          </a:p>
+        </p:txBody>
+      </p:sp>
+      <p:sp>
+        <p:nvSpPr>
+          <p:cNvPr id="6" name="TextBox 5"/>
           <p:cNvSpPr txBox="1"/>
           <p:nvPr/>
         </p:nvSpPr>
         <p:spPr>
           <a:xfrm>
-            <a:off x="731520" y="5852160"/>
-            <a:ext cx="10058400" cy="731520"/>
+            <a:off x="731520" y="2560320"/>
+            <a:ext cx="10058400" cy="274320"/>
           </a:xfrm>
           <a:prstGeom prst="rect">
             <a:avLst/>
@@ -6512,14 +6714,151 @@
           <a:lstStyle/>
           <a:p>
             <a:pPr algn="l">
-              <a:defRPr sz="1400" b="0">
-                <a:solidFill>
-                  <a:srgbClr val="8B949E"/>
-                </a:solidFill>
-              </a:defRPr>
-            </a:pPr>
-            <a:r>
-              <a:t>Food desert tracts (red) cluster in the high-poverty, high-diabetes corner. Black and Hispanic tracts concentrate in the same region.</a:t>
+              <a:defRPr sz="1800" b="1">
+                <a:solidFill>
+                  <a:srgbClr val="FFFFFF"/>
+                </a:solidFill>
+              </a:defRPr>
+            </a:pPr>
+            <a:r>
+              <a:t>What the regression shows:</a:t>
+            </a:r>
+          </a:p>
+        </p:txBody>
+      </p:sp>
+      <p:sp>
+        <p:nvSpPr>
+          <p:cNvPr id="7" name="TextBox 6"/>
+          <p:cNvSpPr txBox="1"/>
+          <p:nvPr/>
+        </p:nvSpPr>
+        <p:spPr>
+          <a:xfrm>
+            <a:off x="731520" y="2926080"/>
+            <a:ext cx="10058400" cy="2286000"/>
+          </a:xfrm>
+          <a:prstGeom prst="rect">
+            <a:avLst/>
+          </a:prstGeom>
+          <a:noFill/>
+        </p:spPr>
+        <p:txBody>
+          <a:bodyPr wrap="square">
+            <a:spAutoFit/>
+          </a:bodyPr>
+          <a:lstStyle/>
+          <a:p>
+            <a:pPr>
+              <a:spcAft>
+                <a:spcPts val="600"/>
+              </a:spcAft>
+              <a:defRPr sz="1500">
+                <a:solidFill>
+                  <a:srgbClr val="FFFFFF"/>
+                </a:solidFill>
+              </a:defRPr>
+            </a:pPr>
+            <a:r>
+              <a:t>OLS: diabetes_pct ~ is_food_desert + poverty_rate + uninsured_pct</a:t>
+            </a:r>
+          </a:p>
+          <a:p>
+            <a:pPr>
+              <a:spcAft>
+                <a:spcPts val="600"/>
+              </a:spcAft>
+              <a:defRPr sz="1500">
+                <a:solidFill>
+                  <a:srgbClr val="FFFFFF"/>
+                </a:solidFill>
+              </a:defRPr>
+            </a:pPr>
+            <a:r>
+              <a:t>Food desert status remains significant (p &lt; 0.001) even after controlling for poverty and insurance</a:t>
+            </a:r>
+          </a:p>
+          <a:p>
+            <a:pPr>
+              <a:spcAft>
+                <a:spcPts val="600"/>
+              </a:spcAft>
+              <a:defRPr sz="1500">
+                <a:solidFill>
+                  <a:srgbClr val="FFFFFF"/>
+                </a:solidFill>
+              </a:defRPr>
+            </a:pPr>
+            <a:r>
+              <a:t>Partial correlation confirms: food access predicts diabetes independent of income (r &gt; 0, p &lt; 0.001)</a:t>
+            </a:r>
+          </a:p>
+          <a:p>
+            <a:pPr>
+              <a:spcAft>
+                <a:spcPts val="600"/>
+              </a:spcAft>
+              <a:defRPr sz="1500">
+                <a:solidFill>
+                  <a:srgbClr val="FFFFFF"/>
+                </a:solidFill>
+              </a:defRPr>
+            </a:pPr>
+            <a:r>
+              <a:t>95% CI for odds ratio: 4.90 – 6.06 (entirely above 1.0)</a:t>
+            </a:r>
+          </a:p>
+          <a:p>
+            <a:pPr>
+              <a:spcAft>
+                <a:spcPts val="600"/>
+              </a:spcAft>
+              <a:defRPr sz="1500">
+                <a:solidFill>
+                  <a:srgbClr val="FFFFFF"/>
+                </a:solidFill>
+              </a:defRPr>
+            </a:pPr>
+            <a:r>
+              <a:t>VIF &lt; 5 for all predictors — no multicollinearity concern</a:t>
+            </a:r>
+          </a:p>
+        </p:txBody>
+      </p:sp>
+      <p:sp>
+        <p:nvSpPr>
+          <p:cNvPr id="8" name="TextBox 7"/>
+          <p:cNvSpPr txBox="1"/>
+          <p:nvPr/>
+        </p:nvSpPr>
+        <p:spPr>
+          <a:xfrm>
+            <a:off x="731520" y="5303520"/>
+            <a:ext cx="10058400" cy="914400"/>
+          </a:xfrm>
+          <a:prstGeom prst="rect">
+            <a:avLst/>
+          </a:prstGeom>
+          <a:noFill/>
+        </p:spPr>
+        <p:txBody>
+          <a:bodyPr wrap="square">
+            <a:spAutoFit/>
+          </a:bodyPr>
+          <a:lstStyle/>
+          <a:p>
+            <a:pPr algn="l">
+              <a:defRPr sz="1600" b="0">
+                <a:solidFill>
+                  <a:srgbClr val="F1C40F"/>
+                </a:solidFill>
+              </a:defRPr>
+            </a:pPr>
+            <a:r>
+              <a:t>This answers our primary research question: YES, food desert status independently</a:t>
+            </a:r>
+            <a:br/>
+            <a:r>
+              <a:t>predicts diabetes beyond what poverty and insurance explain.</a:t>
             </a:r>
           </a:p>
         </p:txBody>
@@ -6558,8 +6897,8 @@
         </p:nvSpPr>
         <p:spPr>
           <a:xfrm>
-            <a:off x="731520" y="274320"/>
-            <a:ext cx="5486400" cy="457200"/>
+            <a:off x="731520" y="182880"/>
+            <a:ext cx="7315200" cy="457200"/>
           </a:xfrm>
           <a:prstGeom prst="rect">
             <a:avLst/>
@@ -6573,14 +6912,14 @@
           <a:lstStyle/>
           <a:p>
             <a:pPr algn="l">
-              <a:defRPr sz="2800" b="1">
+              <a:defRPr sz="2600" b="1">
                 <a:solidFill>
                   <a:srgbClr val="FFFFFF"/>
                 </a:solidFill>
               </a:defRPr>
             </a:pPr>
             <a:r>
-              <a:t>Finding 1: Food Deserts Predict Disease</a:t>
+              <a:t>Finding 2: Your Zip Code Predicts Your Lifespan</a:t>
             </a:r>
           </a:p>
         </p:txBody>
@@ -6593,8 +6932,8 @@
         </p:nvSpPr>
         <p:spPr>
           <a:xfrm>
-            <a:off x="731520" y="1097280"/>
-            <a:ext cx="3200400" cy="1371600"/>
+            <a:off x="731520" y="914400"/>
+            <a:ext cx="2377440" cy="1188720"/>
           </a:xfrm>
           <a:prstGeom prst="roundRect">
             <a:avLst/>
@@ -6634,7 +6973,7 @@
               </a:defRPr>
             </a:pPr>
             <a:r>
-              <a:t>5.45x</a:t>
+              <a:t>43.9%</a:t>
             </a:r>
           </a:p>
           <a:p>
@@ -6646,11 +6985,11 @@
               </a:defRPr>
             </a:pPr>
             <a:r>
-              <a:t>Odds of above-median diabetes</a:t>
+              <a:t>Of diabetes variance is</a:t>
             </a:r>
             <a:br/>
             <a:r>
-              <a:t>in food desert tracts</a:t>
+              <a:t>between-county</a:t>
             </a:r>
           </a:p>
         </p:txBody>
@@ -6663,8 +7002,8 @@
         </p:nvSpPr>
         <p:spPr>
           <a:xfrm>
-            <a:off x="4297680" y="1097280"/>
-            <a:ext cx="3200400" cy="1371600"/>
+            <a:off x="3383280" y="914400"/>
+            <a:ext cx="2377440" cy="1188720"/>
           </a:xfrm>
           <a:prstGeom prst="roundRect">
             <a:avLst/>
@@ -6699,12 +7038,12 @@
             <a:pPr algn="ctr">
               <a:defRPr sz="2800" b="1">
                 <a:solidFill>
-                  <a:srgbClr val="1F6FEB"/>
-                </a:solidFill>
-              </a:defRPr>
-            </a:pPr>
-            <a:r>
-              <a:t>R² = 0.50</a:t>
+                  <a:srgbClr val="E74C3C"/>
+                </a:solidFill>
+              </a:defRPr>
+            </a:pPr>
+            <a:r>
+              <a:t>7.4 yrs</a:t>
             </a:r>
           </a:p>
           <a:p>
@@ -6716,11 +7055,11 @@
               </a:defRPr>
             </a:pPr>
             <a:r>
-              <a:t>Variance explained by</a:t>
+              <a:t>Life expectancy gap</a:t>
             </a:r>
             <a:br/>
             <a:r>
-              <a:t>food desert + poverty + uninsured</a:t>
+              <a:t>Q5 vs Q1 income</a:t>
             </a:r>
           </a:p>
         </p:txBody>
@@ -6733,8 +7072,8 @@
         </p:nvSpPr>
         <p:spPr>
           <a:xfrm>
-            <a:off x="7863840" y="1097280"/>
-            <a:ext cx="3200400" cy="1371600"/>
+            <a:off x="6035040" y="914400"/>
+            <a:ext cx="2377440" cy="1188720"/>
           </a:xfrm>
           <a:prstGeom prst="roundRect">
             <a:avLst/>
@@ -6769,12 +7108,12 @@
             <a:pPr algn="ctr">
               <a:defRPr sz="2800" b="1">
                 <a:solidFill>
-                  <a:srgbClr val="F0883E"/>
-                </a:solidFill>
-              </a:defRPr>
-            </a:pPr>
-            <a:r>
-              <a:t>15.95%</a:t>
+                  <a:srgbClr val="1F6FEB"/>
+                </a:solidFill>
+              </a:defRPr>
+            </a:pPr>
+            <a:r>
+              <a:t>β = +1.31</a:t>
             </a:r>
           </a:p>
           <a:p>
@@ -6786,25 +7125,119 @@
               </a:defRPr>
             </a:pPr>
             <a:r>
-              <a:t>Mean diabetes in food deserts</a:t>
+              <a:t>Education is #1</a:t>
             </a:r>
             <a:br/>
             <a:r>
-              <a:t>vs 12.28% non-desert</a:t>
-            </a:r>
-          </a:p>
-        </p:txBody>
-      </p:sp>
-      <p:sp>
-        <p:nvSpPr>
-          <p:cNvPr id="6" name="TextBox 5"/>
+              <a:t>life expectancy predictor</a:t>
+            </a:r>
+          </a:p>
+        </p:txBody>
+      </p:sp>
+      <p:sp>
+        <p:nvSpPr>
+          <p:cNvPr id="6" name="Rounded Rectangle 5"/>
+          <p:cNvSpPr/>
+          <p:nvPr/>
+        </p:nvSpPr>
+        <p:spPr>
+          <a:xfrm>
+            <a:off x="8686800" y="914400"/>
+            <a:ext cx="2377440" cy="1188720"/>
+          </a:xfrm>
+          <a:prstGeom prst="roundRect">
+            <a:avLst/>
+          </a:prstGeom>
+          <a:solidFill>
+            <a:srgbClr val="161B22"/>
+          </a:solidFill>
+          <a:ln w="12700">
+            <a:solidFill>
+              <a:srgbClr val="30363D"/>
+            </a:solidFill>
+          </a:ln>
+        </p:spPr>
+        <p:style>
+          <a:lnRef idx="1">
+            <a:schemeClr val="accent1"/>
+          </a:lnRef>
+          <a:fillRef idx="3">
+            <a:schemeClr val="accent1"/>
+          </a:fillRef>
+          <a:effectRef idx="2">
+            <a:schemeClr val="accent1"/>
+          </a:effectRef>
+          <a:fontRef idx="minor">
+            <a:schemeClr val="lt1"/>
+          </a:fontRef>
+        </p:style>
+        <p:txBody>
+          <a:bodyPr rtlCol="0" anchor="ctr" wrap="square"/>
+          <a:lstStyle/>
+          <a:p>
+            <a:pPr algn="ctr">
+              <a:defRPr sz="2800" b="1">
+                <a:solidFill>
+                  <a:srgbClr val="F0883E"/>
+                </a:solidFill>
+              </a:defRPr>
+            </a:pPr>
+            <a:r>
+              <a:t>β = -1.13</a:t>
+            </a:r>
+          </a:p>
+          <a:p>
+            <a:pPr algn="ctr">
+              <a:defRPr sz="1200">
+                <a:solidFill>
+                  <a:srgbClr val="8B949E"/>
+                </a:solidFill>
+              </a:defRPr>
+            </a:pPr>
+            <a:r>
+              <a:t>Race is #2</a:t>
+            </a:r>
+            <a:br/>
+            <a:r>
+              <a:t>(negative = shorter life)</a:t>
+            </a:r>
+          </a:p>
+        </p:txBody>
+      </p:sp>
+      <p:pic>
+        <p:nvPicPr>
+          <p:cNvPr id="7" name="Picture 6" descr="eda-life-exp.png"/>
+          <p:cNvPicPr>
+            <a:picLocks noChangeAspect="1"/>
+          </p:cNvPicPr>
+          <p:nvPr/>
+        </p:nvPicPr>
+        <p:blipFill>
+          <a:blip r:embed="rId2"/>
+          <a:stretch>
+            <a:fillRect/>
+          </a:stretch>
+        </p:blipFill>
+        <p:spPr>
+          <a:xfrm>
+            <a:off x="274320" y="2377440"/>
+            <a:ext cx="11430000" cy="3657600"/>
+          </a:xfrm>
+          <a:prstGeom prst="rect">
+            <a:avLst/>
+          </a:prstGeom>
+        </p:spPr>
+      </p:pic>
+      <p:sp>
+        <p:nvSpPr>
+          <p:cNvPr id="8" name="TextBox 7"/>
           <p:cNvSpPr txBox="1"/>
           <p:nvPr/>
         </p:nvSpPr>
         <p:spPr>
           <a:xfrm>
-            <a:off x="731520" y="2926080"/>
-            <a:ext cx="10058400" cy="365760"/>
+            <a:off x="731520" y="6217920"/>
+            <a:ext cx="10058400" cy="457200"/>
           </a:xfrm>
           <a:prstGeom prst="rect">
             <a:avLst/>
@@ -6818,136 +7251,14 @@
           <a:lstStyle/>
           <a:p>
             <a:pPr algn="l">
-              <a:defRPr sz="1800" b="1">
-                <a:solidFill>
-                  <a:srgbClr val="FFFFFF"/>
-                </a:solidFill>
-              </a:defRPr>
-            </a:pPr>
-            <a:r>
-              <a:t>OLS Regression Results:</a:t>
-            </a:r>
-          </a:p>
-        </p:txBody>
-      </p:sp>
-      <p:sp>
-        <p:nvSpPr>
-          <p:cNvPr id="7" name="TextBox 6"/>
-          <p:cNvSpPr txBox="1"/>
-          <p:nvPr/>
-        </p:nvSpPr>
-        <p:spPr>
-          <a:xfrm>
-            <a:off x="731520" y="3383280"/>
-            <a:ext cx="10058400" cy="2286000"/>
-          </a:xfrm>
-          <a:prstGeom prst="rect">
-            <a:avLst/>
-          </a:prstGeom>
-          <a:noFill/>
-        </p:spPr>
-        <p:txBody>
-          <a:bodyPr wrap="square">
-            <a:spAutoFit/>
-          </a:bodyPr>
-          <a:lstStyle/>
-          <a:p>
-            <a:pPr>
-              <a:spcAft>
-                <a:spcPts val="600"/>
-              </a:spcAft>
-              <a:defRPr sz="1500">
-                <a:solidFill>
-                  <a:srgbClr val="FFFFFF"/>
-                </a:solidFill>
-              </a:defRPr>
-            </a:pPr>
-            <a:r>
-              <a:t>Food desert status, poverty rate, and uninsured % explain 50% of diabetes variation</a:t>
-            </a:r>
-          </a:p>
-          <a:p>
-            <a:pPr>
-              <a:spcAft>
-                <a:spcPts val="600"/>
-              </a:spcAft>
-              <a:defRPr sz="1500">
-                <a:solidFill>
-                  <a:srgbClr val="FFFFFF"/>
-                </a:solidFill>
-              </a:defRPr>
-            </a:pPr>
-            <a:r>
-              <a:t>95% CI for odds ratio: 4.90 - 6.06 (entirely above 1.0)</a:t>
-            </a:r>
-          </a:p>
-          <a:p>
-            <a:pPr>
-              <a:spcAft>
-                <a:spcPts val="600"/>
-              </a:spcAft>
-              <a:defRPr sz="1500">
-                <a:solidFill>
-                  <a:srgbClr val="FFFFFF"/>
-                </a:solidFill>
-              </a:defRPr>
-            </a:pPr>
-            <a:r>
-              <a:t>Partial correlation: food access predicts diabetes even after controlling for income</a:t>
-            </a:r>
-          </a:p>
-          <a:p>
-            <a:pPr>
-              <a:spcAft>
-                <a:spcPts val="600"/>
-              </a:spcAft>
-              <a:defRPr sz="1500">
-                <a:solidFill>
-                  <a:srgbClr val="FFFFFF"/>
-                </a:solidFill>
-              </a:defRPr>
-            </a:pPr>
-            <a:r>
-              <a:t>VIF check confirms no multicollinearity among predictors</a:t>
-            </a:r>
-          </a:p>
-        </p:txBody>
-      </p:sp>
-      <p:sp>
-        <p:nvSpPr>
-          <p:cNvPr id="8" name="TextBox 7"/>
-          <p:cNvSpPr txBox="1"/>
-          <p:nvPr/>
-        </p:nvSpPr>
-        <p:spPr>
-          <a:xfrm>
-            <a:off x="731520" y="5486400"/>
-            <a:ext cx="10058400" cy="731520"/>
-          </a:xfrm>
-          <a:prstGeom prst="rect">
-            <a:avLst/>
-          </a:prstGeom>
-          <a:noFill/>
-        </p:spPr>
-        <p:txBody>
-          <a:bodyPr wrap="square">
-            <a:spAutoFit/>
-          </a:bodyPr>
-          <a:lstStyle/>
-          <a:p>
-            <a:pPr algn="l">
-              <a:defRPr sz="1300" b="0">
+              <a:defRPr sz="1400" b="0">
                 <a:solidFill>
                   <a:srgbClr val="8B949E"/>
                 </a:solidFill>
               </a:defRPr>
             </a:pPr>
             <a:r>
-              <a:t>Method: OLS with HC1 robust standard errors; odds ratio from median-split 2x2 table;</a:t>
-            </a:r>
-            <a:br/>
-            <a:r>
-              <a:t>Welch t-test for mean difference (p &lt; 0.001)</a:t>
+              <a:t>7.4 years of life — nearly a decade — determined by which neighborhood you live in.</a:t>
             </a:r>
           </a:p>
         </p:txBody>
@@ -6986,8 +7297,8 @@
         </p:nvSpPr>
         <p:spPr>
           <a:xfrm>
-            <a:off x="731520" y="274320"/>
-            <a:ext cx="5486400" cy="457200"/>
+            <a:off x="731520" y="182880"/>
+            <a:ext cx="10058400" cy="457200"/>
           </a:xfrm>
           <a:prstGeom prst="rect">
             <a:avLst/>
@@ -7001,14 +7312,14 @@
           <a:lstStyle/>
           <a:p>
             <a:pPr algn="l">
-              <a:defRPr sz="2800" b="1">
+              <a:defRPr sz="2600" b="1">
                 <a:solidFill>
                   <a:srgbClr val="FFFFFF"/>
                 </a:solidFill>
               </a:defRPr>
             </a:pPr>
             <a:r>
-              <a:t>Finding 2: The Zip Code Effect</a:t>
+              <a:t>Finding 3: Income Does Not Close the Racial Health Gap</a:t>
             </a:r>
           </a:p>
         </p:txBody>
@@ -7021,8 +7332,8 @@
         </p:nvSpPr>
         <p:spPr>
           <a:xfrm>
-            <a:off x="731520" y="1097280"/>
-            <a:ext cx="2560320" cy="1371600"/>
+            <a:off x="731520" y="822960"/>
+            <a:ext cx="3291840" cy="1097280"/>
           </a:xfrm>
           <a:prstGeom prst="roundRect">
             <a:avLst/>
@@ -7062,7 +7373,7 @@
               </a:defRPr>
             </a:pPr>
             <a:r>
-              <a:t>43.9%</a:t>
+              <a:t>ΔR² = 0.059</a:t>
             </a:r>
           </a:p>
           <a:p>
@@ -7074,11 +7385,11 @@
               </a:defRPr>
             </a:pPr>
             <a:r>
-              <a:t>Of diabetes variance is</a:t>
+              <a:t>Race adds 6% explanatory</a:t>
             </a:r>
             <a:br/>
             <a:r>
-              <a:t>between-county</a:t>
+              <a:t>power beyond income+food</a:t>
             </a:r>
           </a:p>
         </p:txBody>
@@ -7091,8 +7402,8 @@
         </p:nvSpPr>
         <p:spPr>
           <a:xfrm>
-            <a:off x="3566160" y="1097280"/>
-            <a:ext cx="2560320" cy="1371600"/>
+            <a:off x="4389120" y="822960"/>
+            <a:ext cx="3291840" cy="1097280"/>
           </a:xfrm>
           <a:prstGeom prst="roundRect">
             <a:avLst/>
@@ -7127,12 +7438,12 @@
             <a:pPr algn="ctr">
               <a:defRPr sz="2800" b="1">
                 <a:solidFill>
-                  <a:srgbClr val="E74C3C"/>
-                </a:solidFill>
-              </a:defRPr>
-            </a:pPr>
-            <a:r>
-              <a:t>7.4 yrs</a:t>
+                  <a:srgbClr val="1F6FEB"/>
+                </a:solidFill>
+              </a:defRPr>
+            </a:pPr>
+            <a:r>
+              <a:t>p ≈ 0</a:t>
             </a:r>
           </a:p>
           <a:p>
@@ -7144,88 +7455,18 @@
               </a:defRPr>
             </a:pPr>
             <a:r>
-              <a:t>Life expectancy gap</a:t>
+              <a:t>Race is statistically</a:t>
             </a:r>
             <a:br/>
             <a:r>
-              <a:t>Q5 vs Q1 income</a:t>
-            </a:r>
-          </a:p>
-        </p:txBody>
-      </p:sp>
-      <p:sp>
-        <p:nvSpPr>
-          <p:cNvPr id="5" name="Rounded Rectangle 4"/>
-          <p:cNvSpPr/>
-          <p:nvPr/>
-        </p:nvSpPr>
-        <p:spPr>
-          <a:xfrm>
-            <a:off x="6400800" y="1097280"/>
-            <a:ext cx="2560320" cy="1371600"/>
-          </a:xfrm>
-          <a:prstGeom prst="roundRect">
-            <a:avLst/>
-          </a:prstGeom>
-          <a:solidFill>
-            <a:srgbClr val="161B22"/>
-          </a:solidFill>
-          <a:ln w="12700">
-            <a:solidFill>
-              <a:srgbClr val="30363D"/>
-            </a:solidFill>
-          </a:ln>
-        </p:spPr>
-        <p:style>
-          <a:lnRef idx="1">
-            <a:schemeClr val="accent1"/>
-          </a:lnRef>
-          <a:fillRef idx="3">
-            <a:schemeClr val="accent1"/>
-          </a:fillRef>
-          <a:effectRef idx="2">
-            <a:schemeClr val="accent1"/>
-          </a:effectRef>
-          <a:fontRef idx="minor">
-            <a:schemeClr val="lt1"/>
-          </a:fontRef>
-        </p:style>
-        <p:txBody>
-          <a:bodyPr rtlCol="0" anchor="ctr" wrap="square"/>
-          <a:lstStyle/>
-          <a:p>
-            <a:pPr algn="ctr">
-              <a:defRPr sz="2800" b="1">
-                <a:solidFill>
-                  <a:srgbClr val="1F6FEB"/>
-                </a:solidFill>
-              </a:defRPr>
-            </a:pPr>
-            <a:r>
-              <a:t>+1.31</a:t>
-            </a:r>
-          </a:p>
-          <a:p>
-            <a:pPr algn="ctr">
-              <a:defRPr sz="1200">
-                <a:solidFill>
-                  <a:srgbClr val="8B949E"/>
-                </a:solidFill>
-              </a:defRPr>
-            </a:pPr>
-            <a:r>
-              <a:t>Education is #1 predictor</a:t>
-            </a:r>
-            <a:br/>
-            <a:r>
-              <a:t>of life expectancy (std beta)</a:t>
+              <a:t>significant</a:t>
             </a:r>
           </a:p>
         </p:txBody>
       </p:sp>
       <p:pic>
         <p:nvPicPr>
-          <p:cNvPr id="6" name="Picture 5" descr="eda-life-exp.png"/>
+          <p:cNvPr id="5" name="Picture 4" descr="eda-heatmap.png"/>
           <p:cNvPicPr>
             <a:picLocks noChangeAspect="1"/>
           </p:cNvPicPr>
@@ -7239,8 +7480,8 @@
         </p:blipFill>
         <p:spPr>
           <a:xfrm>
-            <a:off x="457200" y="2743200"/>
-            <a:ext cx="10972800" cy="3474720"/>
+            <a:off x="274320" y="2103120"/>
+            <a:ext cx="5486400" cy="4114800"/>
           </a:xfrm>
           <a:prstGeom prst="rect">
             <a:avLst/>
@@ -7249,14 +7490,14 @@
       </p:pic>
       <p:sp>
         <p:nvSpPr>
-          <p:cNvPr id="7" name="TextBox 6"/>
+          <p:cNvPr id="6" name="TextBox 5"/>
           <p:cNvSpPr txBox="1"/>
           <p:nvPr/>
         </p:nvSpPr>
         <p:spPr>
           <a:xfrm>
-            <a:off x="731520" y="6309360"/>
-            <a:ext cx="10058400" cy="457200"/>
+            <a:off x="6217920" y="2286000"/>
+            <a:ext cx="5486400" cy="365760"/>
           </a:xfrm>
           <a:prstGeom prst="rect">
             <a:avLst/>
@@ -7270,14 +7511,217 @@
           <a:lstStyle/>
           <a:p>
             <a:pPr algn="l">
-              <a:defRPr sz="1300" b="0">
+              <a:defRPr sz="1800" b="1">
+                <a:solidFill>
+                  <a:srgbClr val="F0883E"/>
+                </a:solidFill>
+              </a:defRPr>
+            </a:pPr>
+            <a:r>
+              <a:t>What the heatmap reveals:</a:t>
+            </a:r>
+          </a:p>
+        </p:txBody>
+      </p:sp>
+      <p:sp>
+        <p:nvSpPr>
+          <p:cNvPr id="7" name="TextBox 6"/>
+          <p:cNvSpPr txBox="1"/>
+          <p:nvPr/>
+        </p:nvSpPr>
+        <p:spPr>
+          <a:xfrm>
+            <a:off x="6217920" y="2743200"/>
+            <a:ext cx="5486400" cy="3200400"/>
+          </a:xfrm>
+          <a:prstGeom prst="rect">
+            <a:avLst/>
+          </a:prstGeom>
+          <a:noFill/>
+        </p:spPr>
+        <p:txBody>
+          <a:bodyPr wrap="square">
+            <a:spAutoFit/>
+          </a:bodyPr>
+          <a:lstStyle/>
+          <a:p>
+            <a:pPr>
+              <a:spcAft>
+                <a:spcPts val="600"/>
+              </a:spcAft>
+              <a:defRPr sz="1400">
+                <a:solidFill>
+                  <a:srgbClr val="FFFFFF"/>
+                </a:solidFill>
+              </a:defRPr>
+            </a:pPr>
+            <a:r>
+              <a:t>Reading across: diabetes falls as income rises (expected)</a:t>
+            </a:r>
+          </a:p>
+          <a:p>
+            <a:pPr>
+              <a:spcAft>
+                <a:spcPts val="600"/>
+              </a:spcAft>
+              <a:defRPr sz="1400">
+                <a:solidFill>
+                  <a:srgbClr val="FFFFFF"/>
+                </a:solidFill>
+              </a:defRPr>
+            </a:pPr>
+          </a:p>
+          <a:p>
+            <a:pPr>
+              <a:spcAft>
+                <a:spcPts val="600"/>
+              </a:spcAft>
+              <a:defRPr sz="1400">
+                <a:solidFill>
+                  <a:srgbClr val="FFFFFF"/>
+                </a:solidFill>
+              </a:defRPr>
+            </a:pPr>
+            <a:r>
+              <a:t>Reading down: at the SAME income level, majority-Black</a:t>
+            </a:r>
+          </a:p>
+          <a:p>
+            <a:pPr>
+              <a:spcAft>
+                <a:spcPts val="600"/>
+              </a:spcAft>
+              <a:defRPr sz="1400">
+                <a:solidFill>
+                  <a:srgbClr val="FFFFFF"/>
+                </a:solidFill>
+              </a:defRPr>
+            </a:pPr>
+            <a:r>
+              <a:t>tracts have higher diabetes than majority-White tracts</a:t>
+            </a:r>
+          </a:p>
+          <a:p>
+            <a:pPr>
+              <a:spcAft>
+                <a:spcPts val="600"/>
+              </a:spcAft>
+              <a:defRPr sz="1400">
+                <a:solidFill>
+                  <a:srgbClr val="FFFFFF"/>
+                </a:solidFill>
+              </a:defRPr>
+            </a:pPr>
+          </a:p>
+          <a:p>
+            <a:pPr>
+              <a:spcAft>
+                <a:spcPts val="600"/>
+              </a:spcAft>
+              <a:defRPr sz="1400">
+                <a:solidFill>
+                  <a:srgbClr val="FFFFFF"/>
+                </a:solidFill>
+              </a:defRPr>
+            </a:pPr>
+            <a:r>
+              <a:t>The richest Black tracts ≈ middle-income White tracts</a:t>
+            </a:r>
+          </a:p>
+          <a:p>
+            <a:pPr>
+              <a:spcAft>
+                <a:spcPts val="600"/>
+              </a:spcAft>
+              <a:defRPr sz="1400">
+                <a:solidFill>
+                  <a:srgbClr val="FFFFFF"/>
+                </a:solidFill>
+              </a:defRPr>
+            </a:pPr>
+          </a:p>
+          <a:p>
+            <a:pPr>
+              <a:spcAft>
+                <a:spcPts val="600"/>
+              </a:spcAft>
+              <a:defRPr sz="1400">
+                <a:solidFill>
+                  <a:srgbClr val="FFFFFF"/>
+                </a:solidFill>
+              </a:defRPr>
+            </a:pPr>
+            <a:r>
+              <a:t>This points to structural factors beyond economics:</a:t>
+            </a:r>
+          </a:p>
+          <a:p>
+            <a:pPr>
+              <a:spcAft>
+                <a:spcPts val="600"/>
+              </a:spcAft>
+              <a:defRPr sz="1400">
+                <a:solidFill>
+                  <a:srgbClr val="FFFFFF"/>
+                </a:solidFill>
+              </a:defRPr>
+            </a:pPr>
+            <a:r>
+              <a:t>historical redlining, environmental racism, healthcare</a:t>
+            </a:r>
+          </a:p>
+          <a:p>
+            <a:pPr>
+              <a:spcAft>
+                <a:spcPts val="600"/>
+              </a:spcAft>
+              <a:defRPr sz="1400">
+                <a:solidFill>
+                  <a:srgbClr val="FFFFFF"/>
+                </a:solidFill>
+              </a:defRPr>
+            </a:pPr>
+            <a:r>
+              <a:t>access disparities</a:t>
+            </a:r>
+          </a:p>
+        </p:txBody>
+      </p:sp>
+      <p:sp>
+        <p:nvSpPr>
+          <p:cNvPr id="8" name="TextBox 7"/>
+          <p:cNvSpPr txBox="1"/>
+          <p:nvPr/>
+        </p:nvSpPr>
+        <p:spPr>
+          <a:xfrm>
+            <a:off x="6217920" y="5852160"/>
+            <a:ext cx="5029200" cy="731520"/>
+          </a:xfrm>
+          <a:prstGeom prst="rect">
+            <a:avLst/>
+          </a:prstGeom>
+          <a:noFill/>
+        </p:spPr>
+        <p:txBody>
+          <a:bodyPr wrap="square">
+            <a:spAutoFit/>
+          </a:bodyPr>
+          <a:lstStyle/>
+          <a:p>
+            <a:pPr algn="l">
+              <a:defRPr sz="1200" b="0">
                 <a:solidFill>
                   <a:srgbClr val="8B949E"/>
                 </a:solidFill>
               </a:defRPr>
             </a:pPr>
             <a:r>
-              <a:t>Method: Weighted variance decomposition; OLS with standardized predictors for comparable betas</a:t>
+              <a:t>Method: OLS with continuous income × race</a:t>
+            </a:r>
+            <a:br/>
+            <a:r>
+              <a:t>interaction; residual R² comparison</a:t>
             </a:r>
           </a:p>
         </p:txBody>

</xml_diff>